<commit_message>
Put the Jewell mark in the masthead, on both the sheet and the slide
The wordmark takes the right margin and the chips run back from it. The
solid "Jewell Projects" chip that used to hold that corner is gone, because
the mark and a chip spelling out the same words is saying it twice.

Sized off the wordmark's own 720x159, at 5.4mm tall, and the CSS rule is
scoped to the plan sheets so the Discover, Design and Deploy sheets keep
the masthead they already have.

Also closed the last thing that read differently between the two media: the
sheets mark the first chip with .chip.gate in accent and the extractor was
dropping the class, so every chip in the deck came out the same grey. Chips
now carry their gate flag through.

Right margin measured at 9.0mm on the slide against 9.2mm on the sheet,
which is the 9mm the sheet is padded to.

Co-Authored-By: Claude Opus 5 <noreply@anthropic.com>
Claude-Session: https://claude.ai/code/session_01Asjqk2CJhNThgugfeWzXnb
</commit_message>
<xml_diff>
--- a/00 Admin/11 Final Outputs/plan-on-a-page/TapThat_Plan-on-a-Page_A3.pptx
+++ b/00 Admin/11 Final Outputs/plan-on-a-page/TapThat_Plan-on-a-Page_A3.pptx
@@ -1294,81 +1294,39 @@
           </a:p>
         </p:txBody>
       </p:sp>
-      <p:sp>
-        <p:nvSpPr>
-          <p:cNvPr id="4" name="Shape 1"/>
+      <p:pic>
+        <p:nvPicPr>
+          <p:cNvPr id="4" name="Image 1" descr="../site/brand/jewell-wordmark.png">    </p:cNvPr>
+          <p:cNvPicPr>
+            <a:picLocks noChangeAspect="1"/>
+          </p:cNvPicPr>
+          <p:nvPr/>
+        </p:nvPicPr>
+        <p:blipFill>
+          <a:blip r:embed="rId2"/>
+          <a:stretch>
+            <a:fillRect/>
+          </a:stretch>
+        </p:blipFill>
+        <p:spPr>
+          <a:xfrm>
+            <a:off x="13915605" y="394290"/>
+            <a:ext cx="880302" cy="194400"/>
+          </a:xfrm>
+          <a:prstGeom prst="rect">
+            <a:avLst/>
+          </a:prstGeom>
+        </p:spPr>
+      </p:pic>
+      <p:sp>
+        <p:nvSpPr>
+          <p:cNvPr id="5" name="Shape 1"/>
           <p:cNvSpPr/>
           <p:nvPr/>
         </p:nvSpPr>
         <p:spPr>
           <a:xfrm>
-            <a:off x="13650938" y="365760"/>
-            <a:ext cx="1144969" cy="251460"/>
-          </a:xfrm>
-          <a:prstGeom prst="roundRect">
-            <a:avLst>
-              <a:gd name="adj" fmla="val 50000"/>
-            </a:avLst>
-          </a:prstGeom>
-          <a:solidFill>
-            <a:srgbClr val="0E171F"/>
-          </a:solidFill>
-          <a:ln w="9525">
-            <a:solidFill>
-              <a:srgbClr val="0E171F"/>
-            </a:solidFill>
-            <a:prstDash val="solid"/>
-          </a:ln>
-        </p:spPr>
-      </p:sp>
-      <p:sp>
-        <p:nvSpPr>
-          <p:cNvPr id="5" name="Text 2"/>
-          <p:cNvSpPr txBox="1"/>
-          <p:nvPr/>
-        </p:nvSpPr>
-        <p:spPr>
-          <a:xfrm>
-            <a:off x="13650938" y="365760"/>
-            <a:ext cx="1144969" cy="251460"/>
-          </a:xfrm>
-          <a:prstGeom prst="rect">
-            <a:avLst/>
-          </a:prstGeom>
-          <a:noFill/>
-          <a:ln/>
-        </p:spPr>
-        <p:txBody>
-          <a:bodyPr wrap="square" lIns="0" tIns="0" rIns="0" bIns="0" rtlCol="0" anchor="ctr"/>
-          <a:lstStyle/>
-          <a:p>
-            <a:pPr algn="ctr" indent="0" marL="0">
-              <a:buNone/>
-            </a:pPr>
-            <a:r>
-              <a:rPr lang="en-US" sz="650" b="1" spc="78" kern="0" dirty="0">
-                <a:solidFill>
-                  <a:srgbClr val="FFFFFF"/>
-                </a:solidFill>
-                <a:latin typeface="Poppins" pitchFamily="34" charset="0"/>
-                <a:ea typeface="Poppins" pitchFamily="34" charset="-122"/>
-                <a:cs typeface="Poppins" pitchFamily="34" charset="-120"/>
-              </a:rPr>
-              <a:t>JEWELL PROJECTS</a:t>
-            </a:r>
-            <a:endParaRPr lang="en-US" sz="650" dirty="0"/>
-          </a:p>
-        </p:txBody>
-      </p:sp>
-      <p:sp>
-        <p:nvSpPr>
-          <p:cNvPr id="6" name="Shape 3"/>
-          <p:cNvSpPr/>
-          <p:nvPr/>
-        </p:nvSpPr>
-        <p:spPr>
-          <a:xfrm>
-            <a:off x="12410462" y="365760"/>
+            <a:off x="12693129" y="365760"/>
             <a:ext cx="1150475" cy="251460"/>
           </a:xfrm>
           <a:prstGeom prst="roundRect">
@@ -1389,13 +1347,13 @@
       </p:sp>
       <p:sp>
         <p:nvSpPr>
-          <p:cNvPr id="7" name="Text 4"/>
+          <p:cNvPr id="6" name="Text 2"/>
           <p:cNvSpPr txBox="1"/>
           <p:nvPr/>
         </p:nvSpPr>
         <p:spPr>
           <a:xfrm>
-            <a:off x="12410462" y="365760"/>
+            <a:off x="12693129" y="365760"/>
             <a:ext cx="1150475" cy="251460"/>
           </a:xfrm>
           <a:prstGeom prst="rect">
@@ -1428,13 +1386,13 @@
       </p:sp>
       <p:sp>
         <p:nvSpPr>
-          <p:cNvPr id="8" name="Shape 5"/>
+          <p:cNvPr id="7" name="Shape 3"/>
           <p:cNvSpPr/>
           <p:nvPr/>
         </p:nvSpPr>
         <p:spPr>
           <a:xfrm>
-            <a:off x="11102419" y="365760"/>
+            <a:off x="11385086" y="365760"/>
             <a:ext cx="1218043" cy="251460"/>
           </a:xfrm>
           <a:prstGeom prst="roundRect">
@@ -1455,13 +1413,13 @@
       </p:sp>
       <p:sp>
         <p:nvSpPr>
-          <p:cNvPr id="9" name="Text 6"/>
+          <p:cNvPr id="8" name="Text 4"/>
           <p:cNvSpPr txBox="1"/>
           <p:nvPr/>
         </p:nvSpPr>
         <p:spPr>
           <a:xfrm>
-            <a:off x="11102419" y="365760"/>
+            <a:off x="11385086" y="365760"/>
             <a:ext cx="1218043" cy="251460"/>
           </a:xfrm>
           <a:prstGeom prst="rect">
@@ -1494,13 +1452,13 @@
       </p:sp>
       <p:sp>
         <p:nvSpPr>
-          <p:cNvPr id="10" name="Shape 7"/>
+          <p:cNvPr id="9" name="Shape 5"/>
           <p:cNvSpPr/>
           <p:nvPr/>
         </p:nvSpPr>
         <p:spPr>
           <a:xfrm>
-            <a:off x="10260952" y="365760"/>
+            <a:off x="10543619" y="365760"/>
             <a:ext cx="751467" cy="251460"/>
           </a:xfrm>
           <a:prstGeom prst="roundRect">
@@ -1513,7 +1471,7 @@
           </a:solidFill>
           <a:ln w="9525">
             <a:solidFill>
-              <a:srgbClr val="E3E7EC"/>
+              <a:srgbClr val="0066FF"/>
             </a:solidFill>
             <a:prstDash val="solid"/>
           </a:ln>
@@ -1521,13 +1479,13 @@
       </p:sp>
       <p:sp>
         <p:nvSpPr>
-          <p:cNvPr id="11" name="Text 8"/>
+          <p:cNvPr id="10" name="Text 6"/>
           <p:cNvSpPr txBox="1"/>
           <p:nvPr/>
         </p:nvSpPr>
         <p:spPr>
           <a:xfrm>
-            <a:off x="10260952" y="365760"/>
+            <a:off x="10543619" y="365760"/>
             <a:ext cx="751467" cy="251460"/>
           </a:xfrm>
           <a:prstGeom prst="rect">
@@ -1546,7 +1504,7 @@
             <a:r>
               <a:rPr lang="en-US" sz="650" b="1" spc="78" kern="0" dirty="0">
                 <a:solidFill>
-                  <a:srgbClr val="4A5565"/>
+                  <a:srgbClr val="0066FF"/>
                 </a:solidFill>
                 <a:latin typeface="Poppins" pitchFamily="34" charset="0"/>
                 <a:ea typeface="Poppins" pitchFamily="34" charset="-122"/>
@@ -1560,7 +1518,7 @@
       </p:sp>
       <p:sp>
         <p:nvSpPr>
-          <p:cNvPr id="12" name="Shape 9"/>
+          <p:cNvPr id="11" name="Shape 7"/>
           <p:cNvSpPr/>
           <p:nvPr/>
         </p:nvSpPr>
@@ -1583,7 +1541,7 @@
       </p:sp>
       <p:sp>
         <p:nvSpPr>
-          <p:cNvPr id="13" name="Shape 10"/>
+          <p:cNvPr id="12" name="Shape 8"/>
           <p:cNvSpPr/>
           <p:nvPr/>
         </p:nvSpPr>
@@ -1608,7 +1566,7 @@
       </p:sp>
       <p:sp>
         <p:nvSpPr>
-          <p:cNvPr id="14" name="Shape 11"/>
+          <p:cNvPr id="13" name="Shape 9"/>
           <p:cNvSpPr/>
           <p:nvPr/>
         </p:nvSpPr>
@@ -1633,7 +1591,7 @@
       </p:sp>
       <p:sp>
         <p:nvSpPr>
-          <p:cNvPr id="15" name="Text 12"/>
+          <p:cNvPr id="14" name="Text 10"/>
           <p:cNvSpPr txBox="1"/>
           <p:nvPr/>
         </p:nvSpPr>
@@ -1675,7 +1633,7 @@
       </p:sp>
       <p:sp>
         <p:nvSpPr>
-          <p:cNvPr id="16" name="Text 13"/>
+          <p:cNvPr id="15" name="Text 11"/>
           <p:cNvSpPr txBox="1"/>
           <p:nvPr/>
         </p:nvSpPr>
@@ -1717,7 +1675,7 @@
       </p:sp>
       <p:sp>
         <p:nvSpPr>
-          <p:cNvPr id="17" name="Text 14"/>
+          <p:cNvPr id="16" name="Text 12"/>
           <p:cNvSpPr txBox="1"/>
           <p:nvPr/>
         </p:nvSpPr>
@@ -1776,7 +1734,7 @@
       </p:sp>
       <p:sp>
         <p:nvSpPr>
-          <p:cNvPr id="18" name="Text 15"/>
+          <p:cNvPr id="17" name="Text 13"/>
           <p:cNvSpPr txBox="1"/>
           <p:nvPr/>
         </p:nvSpPr>
@@ -1835,7 +1793,7 @@
       </p:sp>
       <p:sp>
         <p:nvSpPr>
-          <p:cNvPr id="19" name="Text 16"/>
+          <p:cNvPr id="18" name="Text 14"/>
           <p:cNvSpPr txBox="1"/>
           <p:nvPr/>
         </p:nvSpPr>
@@ -1894,7 +1852,7 @@
       </p:sp>
       <p:sp>
         <p:nvSpPr>
-          <p:cNvPr id="20" name="Shape 17"/>
+          <p:cNvPr id="19" name="Shape 15"/>
           <p:cNvSpPr/>
           <p:nvPr/>
         </p:nvSpPr>
@@ -1917,7 +1875,7 @@
       </p:sp>
       <p:sp>
         <p:nvSpPr>
-          <p:cNvPr id="21" name="Text 18"/>
+          <p:cNvPr id="20" name="Text 16"/>
           <p:cNvSpPr txBox="1"/>
           <p:nvPr/>
         </p:nvSpPr>
@@ -1959,7 +1917,7 @@
       </p:sp>
       <p:sp>
         <p:nvSpPr>
-          <p:cNvPr id="22" name="Shape 19"/>
+          <p:cNvPr id="21" name="Shape 17"/>
           <p:cNvSpPr/>
           <p:nvPr/>
         </p:nvSpPr>
@@ -1984,7 +1942,7 @@
       </p:sp>
       <p:sp>
         <p:nvSpPr>
-          <p:cNvPr id="23" name="Text 20"/>
+          <p:cNvPr id="22" name="Text 18"/>
           <p:cNvSpPr txBox="1"/>
           <p:nvPr/>
         </p:nvSpPr>
@@ -2026,7 +1984,7 @@
       </p:sp>
       <p:sp>
         <p:nvSpPr>
-          <p:cNvPr id="24" name="Shape 21"/>
+          <p:cNvPr id="23" name="Shape 19"/>
           <p:cNvSpPr/>
           <p:nvPr/>
         </p:nvSpPr>
@@ -2051,7 +2009,7 @@
       </p:sp>
       <p:sp>
         <p:nvSpPr>
-          <p:cNvPr id="25" name="Text 22"/>
+          <p:cNvPr id="24" name="Text 20"/>
           <p:cNvSpPr txBox="1"/>
           <p:nvPr/>
         </p:nvSpPr>
@@ -2093,7 +2051,7 @@
       </p:sp>
       <p:sp>
         <p:nvSpPr>
-          <p:cNvPr id="26" name="Text 23"/>
+          <p:cNvPr id="25" name="Text 21"/>
           <p:cNvSpPr txBox="1"/>
           <p:nvPr/>
         </p:nvSpPr>
@@ -2135,7 +2093,7 @@
       </p:sp>
       <p:sp>
         <p:nvSpPr>
-          <p:cNvPr id="27" name="Shape 24"/>
+          <p:cNvPr id="26" name="Shape 22"/>
           <p:cNvSpPr/>
           <p:nvPr/>
         </p:nvSpPr>
@@ -2160,7 +2118,7 @@
       </p:sp>
       <p:sp>
         <p:nvSpPr>
-          <p:cNvPr id="28" name="Text 25"/>
+          <p:cNvPr id="27" name="Text 23"/>
           <p:cNvSpPr txBox="1"/>
           <p:nvPr/>
         </p:nvSpPr>
@@ -2202,7 +2160,7 @@
       </p:sp>
       <p:sp>
         <p:nvSpPr>
-          <p:cNvPr id="29" name="Text 26"/>
+          <p:cNvPr id="28" name="Text 24"/>
           <p:cNvSpPr txBox="1"/>
           <p:nvPr/>
         </p:nvSpPr>
@@ -2244,7 +2202,7 @@
       </p:sp>
       <p:sp>
         <p:nvSpPr>
-          <p:cNvPr id="30" name="Shape 27"/>
+          <p:cNvPr id="29" name="Shape 25"/>
           <p:cNvSpPr/>
           <p:nvPr/>
         </p:nvSpPr>
@@ -2269,7 +2227,7 @@
       </p:sp>
       <p:sp>
         <p:nvSpPr>
-          <p:cNvPr id="31" name="Text 28"/>
+          <p:cNvPr id="30" name="Text 26"/>
           <p:cNvSpPr txBox="1"/>
           <p:nvPr/>
         </p:nvSpPr>
@@ -2311,7 +2269,7 @@
       </p:sp>
       <p:sp>
         <p:nvSpPr>
-          <p:cNvPr id="32" name="Text 29"/>
+          <p:cNvPr id="31" name="Text 27"/>
           <p:cNvSpPr txBox="1"/>
           <p:nvPr/>
         </p:nvSpPr>
@@ -2353,7 +2311,7 @@
       </p:sp>
       <p:sp>
         <p:nvSpPr>
-          <p:cNvPr id="33" name="Shape 30"/>
+          <p:cNvPr id="32" name="Shape 28"/>
           <p:cNvSpPr/>
           <p:nvPr/>
         </p:nvSpPr>
@@ -2378,7 +2336,7 @@
       </p:sp>
       <p:sp>
         <p:nvSpPr>
-          <p:cNvPr id="34" name="Text 31"/>
+          <p:cNvPr id="33" name="Text 29"/>
           <p:cNvSpPr txBox="1"/>
           <p:nvPr/>
         </p:nvSpPr>
@@ -2420,7 +2378,7 @@
       </p:sp>
       <p:sp>
         <p:nvSpPr>
-          <p:cNvPr id="35" name="Text 32"/>
+          <p:cNvPr id="34" name="Text 30"/>
           <p:cNvSpPr txBox="1"/>
           <p:nvPr/>
         </p:nvSpPr>
@@ -2462,7 +2420,7 @@
       </p:sp>
       <p:sp>
         <p:nvSpPr>
-          <p:cNvPr id="36" name="Shape 33"/>
+          <p:cNvPr id="35" name="Shape 31"/>
           <p:cNvSpPr/>
           <p:nvPr/>
         </p:nvSpPr>
@@ -2487,7 +2445,7 @@
       </p:sp>
       <p:sp>
         <p:nvSpPr>
-          <p:cNvPr id="37" name="Text 34"/>
+          <p:cNvPr id="36" name="Text 32"/>
           <p:cNvSpPr txBox="1"/>
           <p:nvPr/>
         </p:nvSpPr>
@@ -2529,7 +2487,7 @@
       </p:sp>
       <p:sp>
         <p:nvSpPr>
-          <p:cNvPr id="38" name="Text 35"/>
+          <p:cNvPr id="37" name="Text 33"/>
           <p:cNvSpPr txBox="1"/>
           <p:nvPr/>
         </p:nvSpPr>
@@ -2571,7 +2529,7 @@
       </p:sp>
       <p:sp>
         <p:nvSpPr>
-          <p:cNvPr id="39" name="Shape 36"/>
+          <p:cNvPr id="38" name="Shape 34"/>
           <p:cNvSpPr/>
           <p:nvPr/>
         </p:nvSpPr>
@@ -2596,7 +2554,7 @@
       </p:sp>
       <p:sp>
         <p:nvSpPr>
-          <p:cNvPr id="40" name="Text 37"/>
+          <p:cNvPr id="39" name="Text 35"/>
           <p:cNvSpPr txBox="1"/>
           <p:nvPr/>
         </p:nvSpPr>
@@ -2638,7 +2596,7 @@
       </p:sp>
       <p:sp>
         <p:nvSpPr>
-          <p:cNvPr id="41" name="Text 38"/>
+          <p:cNvPr id="40" name="Text 36"/>
           <p:cNvSpPr txBox="1"/>
           <p:nvPr/>
         </p:nvSpPr>
@@ -2680,7 +2638,7 @@
       </p:sp>
       <p:sp>
         <p:nvSpPr>
-          <p:cNvPr id="42" name="Shape 39"/>
+          <p:cNvPr id="41" name="Shape 37"/>
           <p:cNvSpPr/>
           <p:nvPr/>
         </p:nvSpPr>
@@ -2705,7 +2663,7 @@
       </p:sp>
       <p:sp>
         <p:nvSpPr>
-          <p:cNvPr id="43" name="Text 40"/>
+          <p:cNvPr id="42" name="Text 38"/>
           <p:cNvSpPr txBox="1"/>
           <p:nvPr/>
         </p:nvSpPr>
@@ -2764,7 +2722,7 @@
       </p:sp>
       <p:sp>
         <p:nvSpPr>
-          <p:cNvPr id="44" name="Shape 41"/>
+          <p:cNvPr id="43" name="Shape 39"/>
           <p:cNvSpPr/>
           <p:nvPr/>
         </p:nvSpPr>
@@ -2789,7 +2747,7 @@
       </p:sp>
       <p:sp>
         <p:nvSpPr>
-          <p:cNvPr id="45" name="Shape 42"/>
+          <p:cNvPr id="44" name="Shape 40"/>
           <p:cNvSpPr/>
           <p:nvPr/>
         </p:nvSpPr>
@@ -2814,7 +2772,7 @@
       </p:sp>
       <p:sp>
         <p:nvSpPr>
-          <p:cNvPr id="46" name="Text 43"/>
+          <p:cNvPr id="45" name="Text 41"/>
           <p:cNvSpPr txBox="1"/>
           <p:nvPr/>
         </p:nvSpPr>
@@ -2856,7 +2814,7 @@
       </p:sp>
       <p:sp>
         <p:nvSpPr>
-          <p:cNvPr id="47" name="Text 44"/>
+          <p:cNvPr id="46" name="Text 42"/>
           <p:cNvSpPr txBox="1"/>
           <p:nvPr/>
         </p:nvSpPr>
@@ -2898,7 +2856,7 @@
       </p:sp>
       <p:sp>
         <p:nvSpPr>
-          <p:cNvPr id="48" name="Text 45"/>
+          <p:cNvPr id="47" name="Text 43"/>
           <p:cNvSpPr txBox="1"/>
           <p:nvPr/>
         </p:nvSpPr>
@@ -2940,7 +2898,7 @@
       </p:sp>
       <p:sp>
         <p:nvSpPr>
-          <p:cNvPr id="49" name="Text 46"/>
+          <p:cNvPr id="48" name="Text 44"/>
           <p:cNvSpPr txBox="1"/>
           <p:nvPr/>
         </p:nvSpPr>
@@ -2999,7 +2957,7 @@
       </p:sp>
       <p:sp>
         <p:nvSpPr>
-          <p:cNvPr id="50" name="Shape 47"/>
+          <p:cNvPr id="49" name="Shape 45"/>
           <p:cNvSpPr/>
           <p:nvPr/>
         </p:nvSpPr>
@@ -3024,7 +2982,7 @@
       </p:sp>
       <p:sp>
         <p:nvSpPr>
-          <p:cNvPr id="51" name="Shape 48"/>
+          <p:cNvPr id="50" name="Shape 46"/>
           <p:cNvSpPr/>
           <p:nvPr/>
         </p:nvSpPr>
@@ -3049,7 +3007,7 @@
       </p:sp>
       <p:sp>
         <p:nvSpPr>
-          <p:cNvPr id="52" name="Text 49"/>
+          <p:cNvPr id="51" name="Text 47"/>
           <p:cNvSpPr txBox="1"/>
           <p:nvPr/>
         </p:nvSpPr>
@@ -3091,7 +3049,7 @@
       </p:sp>
       <p:sp>
         <p:nvSpPr>
-          <p:cNvPr id="53" name="Text 50"/>
+          <p:cNvPr id="52" name="Text 48"/>
           <p:cNvSpPr txBox="1"/>
           <p:nvPr/>
         </p:nvSpPr>
@@ -3133,7 +3091,7 @@
       </p:sp>
       <p:sp>
         <p:nvSpPr>
-          <p:cNvPr id="54" name="Text 51"/>
+          <p:cNvPr id="53" name="Text 49"/>
           <p:cNvSpPr txBox="1"/>
           <p:nvPr/>
         </p:nvSpPr>
@@ -3175,7 +3133,7 @@
       </p:sp>
       <p:sp>
         <p:nvSpPr>
-          <p:cNvPr id="55" name="Text 52"/>
+          <p:cNvPr id="54" name="Text 50"/>
           <p:cNvSpPr txBox="1"/>
           <p:nvPr/>
         </p:nvSpPr>
@@ -3234,7 +3192,7 @@
       </p:sp>
       <p:sp>
         <p:nvSpPr>
-          <p:cNvPr id="56" name="Shape 53"/>
+          <p:cNvPr id="55" name="Shape 51"/>
           <p:cNvSpPr/>
           <p:nvPr/>
         </p:nvSpPr>
@@ -3259,7 +3217,7 @@
       </p:sp>
       <p:sp>
         <p:nvSpPr>
-          <p:cNvPr id="57" name="Shape 54"/>
+          <p:cNvPr id="56" name="Shape 52"/>
           <p:cNvSpPr/>
           <p:nvPr/>
         </p:nvSpPr>
@@ -3284,7 +3242,7 @@
       </p:sp>
       <p:sp>
         <p:nvSpPr>
-          <p:cNvPr id="58" name="Text 55"/>
+          <p:cNvPr id="57" name="Text 53"/>
           <p:cNvSpPr txBox="1"/>
           <p:nvPr/>
         </p:nvSpPr>
@@ -3326,7 +3284,7 @@
       </p:sp>
       <p:sp>
         <p:nvSpPr>
-          <p:cNvPr id="59" name="Text 56"/>
+          <p:cNvPr id="58" name="Text 54"/>
           <p:cNvSpPr txBox="1"/>
           <p:nvPr/>
         </p:nvSpPr>
@@ -3368,7 +3326,7 @@
       </p:sp>
       <p:sp>
         <p:nvSpPr>
-          <p:cNvPr id="60" name="Text 57"/>
+          <p:cNvPr id="59" name="Text 55"/>
           <p:cNvSpPr txBox="1"/>
           <p:nvPr/>
         </p:nvSpPr>
@@ -3410,7 +3368,7 @@
       </p:sp>
       <p:sp>
         <p:nvSpPr>
-          <p:cNvPr id="61" name="Text 58"/>
+          <p:cNvPr id="60" name="Text 56"/>
           <p:cNvSpPr txBox="1"/>
           <p:nvPr/>
         </p:nvSpPr>
@@ -3469,7 +3427,7 @@
       </p:sp>
       <p:sp>
         <p:nvSpPr>
-          <p:cNvPr id="62" name="Shape 59"/>
+          <p:cNvPr id="61" name="Shape 57"/>
           <p:cNvSpPr/>
           <p:nvPr/>
         </p:nvSpPr>
@@ -3494,7 +3452,7 @@
       </p:sp>
       <p:sp>
         <p:nvSpPr>
-          <p:cNvPr id="63" name="Shape 60"/>
+          <p:cNvPr id="62" name="Shape 58"/>
           <p:cNvSpPr/>
           <p:nvPr/>
         </p:nvSpPr>
@@ -3519,7 +3477,7 @@
       </p:sp>
       <p:sp>
         <p:nvSpPr>
-          <p:cNvPr id="64" name="Text 61"/>
+          <p:cNvPr id="63" name="Text 59"/>
           <p:cNvSpPr txBox="1"/>
           <p:nvPr/>
         </p:nvSpPr>
@@ -3561,7 +3519,7 @@
       </p:sp>
       <p:sp>
         <p:nvSpPr>
-          <p:cNvPr id="65" name="Text 62"/>
+          <p:cNvPr id="64" name="Text 60"/>
           <p:cNvSpPr txBox="1"/>
           <p:nvPr/>
         </p:nvSpPr>
@@ -3603,7 +3561,7 @@
       </p:sp>
       <p:sp>
         <p:nvSpPr>
-          <p:cNvPr id="66" name="Text 63"/>
+          <p:cNvPr id="65" name="Text 61"/>
           <p:cNvSpPr txBox="1"/>
           <p:nvPr/>
         </p:nvSpPr>
@@ -3645,7 +3603,7 @@
       </p:sp>
       <p:sp>
         <p:nvSpPr>
-          <p:cNvPr id="67" name="Text 64"/>
+          <p:cNvPr id="66" name="Text 62"/>
           <p:cNvSpPr txBox="1"/>
           <p:nvPr/>
         </p:nvSpPr>
@@ -3704,7 +3662,7 @@
       </p:sp>
       <p:sp>
         <p:nvSpPr>
-          <p:cNvPr id="68" name="Shape 65"/>
+          <p:cNvPr id="67" name="Shape 63"/>
           <p:cNvSpPr/>
           <p:nvPr/>
         </p:nvSpPr>
@@ -3729,7 +3687,7 @@
       </p:sp>
       <p:sp>
         <p:nvSpPr>
-          <p:cNvPr id="69" name="Text 66"/>
+          <p:cNvPr id="68" name="Text 64"/>
           <p:cNvSpPr txBox="1"/>
           <p:nvPr/>
         </p:nvSpPr>
@@ -3771,7 +3729,7 @@
       </p:sp>
       <p:sp>
         <p:nvSpPr>
-          <p:cNvPr id="70" name="Shape 67"/>
+          <p:cNvPr id="69" name="Shape 65"/>
           <p:cNvSpPr/>
           <p:nvPr/>
         </p:nvSpPr>
@@ -3798,7 +3756,7 @@
       </p:sp>
       <p:sp>
         <p:nvSpPr>
-          <p:cNvPr id="71" name="Text 68"/>
+          <p:cNvPr id="70" name="Text 66"/>
           <p:cNvSpPr txBox="1"/>
           <p:nvPr/>
         </p:nvSpPr>
@@ -3837,7 +3795,7 @@
       </p:sp>
       <p:sp>
         <p:nvSpPr>
-          <p:cNvPr id="72" name="Text 69"/>
+          <p:cNvPr id="71" name="Text 67"/>
           <p:cNvSpPr txBox="1"/>
           <p:nvPr/>
         </p:nvSpPr>
@@ -3879,7 +3837,7 @@
       </p:sp>
       <p:sp>
         <p:nvSpPr>
-          <p:cNvPr id="73" name="Shape 70"/>
+          <p:cNvPr id="72" name="Shape 68"/>
           <p:cNvSpPr/>
           <p:nvPr/>
         </p:nvSpPr>
@@ -3906,7 +3864,7 @@
       </p:sp>
       <p:sp>
         <p:nvSpPr>
-          <p:cNvPr id="74" name="Text 71"/>
+          <p:cNvPr id="73" name="Text 69"/>
           <p:cNvSpPr txBox="1"/>
           <p:nvPr/>
         </p:nvSpPr>
@@ -3945,7 +3903,7 @@
       </p:sp>
       <p:sp>
         <p:nvSpPr>
-          <p:cNvPr id="75" name="Text 72"/>
+          <p:cNvPr id="74" name="Text 70"/>
           <p:cNvSpPr txBox="1"/>
           <p:nvPr/>
         </p:nvSpPr>
@@ -3987,7 +3945,7 @@
       </p:sp>
       <p:sp>
         <p:nvSpPr>
-          <p:cNvPr id="76" name="Shape 73"/>
+          <p:cNvPr id="75" name="Shape 71"/>
           <p:cNvSpPr/>
           <p:nvPr/>
         </p:nvSpPr>
@@ -4014,7 +3972,7 @@
       </p:sp>
       <p:sp>
         <p:nvSpPr>
-          <p:cNvPr id="77" name="Text 74"/>
+          <p:cNvPr id="76" name="Text 72"/>
           <p:cNvSpPr txBox="1"/>
           <p:nvPr/>
         </p:nvSpPr>
@@ -4053,7 +4011,7 @@
       </p:sp>
       <p:sp>
         <p:nvSpPr>
-          <p:cNvPr id="78" name="Text 75"/>
+          <p:cNvPr id="77" name="Text 73"/>
           <p:cNvSpPr txBox="1"/>
           <p:nvPr/>
         </p:nvSpPr>
@@ -4095,7 +4053,7 @@
       </p:sp>
       <p:sp>
         <p:nvSpPr>
-          <p:cNvPr id="79" name="Shape 76"/>
+          <p:cNvPr id="78" name="Shape 74"/>
           <p:cNvSpPr/>
           <p:nvPr/>
         </p:nvSpPr>
@@ -4118,7 +4076,7 @@
       </p:sp>
       <p:sp>
         <p:nvSpPr>
-          <p:cNvPr id="80" name="Text 77"/>
+          <p:cNvPr id="79" name="Text 75"/>
           <p:cNvSpPr txBox="1"/>
           <p:nvPr/>
         </p:nvSpPr>
@@ -4160,7 +4118,7 @@
       </p:sp>
       <p:sp>
         <p:nvSpPr>
-          <p:cNvPr id="81" name="Shape 78"/>
+          <p:cNvPr id="80" name="Shape 76"/>
           <p:cNvSpPr/>
           <p:nvPr/>
         </p:nvSpPr>
@@ -4185,7 +4143,7 @@
       </p:sp>
       <p:sp>
         <p:nvSpPr>
-          <p:cNvPr id="82" name="Text 79"/>
+          <p:cNvPr id="81" name="Text 77"/>
           <p:cNvSpPr txBox="1"/>
           <p:nvPr/>
         </p:nvSpPr>
@@ -5385,7 +5343,7 @@
       </p:graphicFrame>
       <p:sp>
         <p:nvSpPr>
-          <p:cNvPr id="84" name="Shape 80"/>
+          <p:cNvPr id="83" name="Shape 78"/>
           <p:cNvSpPr/>
           <p:nvPr/>
         </p:nvSpPr>
@@ -5408,7 +5366,7 @@
       </p:sp>
       <p:sp>
         <p:nvSpPr>
-          <p:cNvPr id="85" name="Text 81"/>
+          <p:cNvPr id="84" name="Text 79"/>
           <p:cNvSpPr txBox="1"/>
           <p:nvPr/>
         </p:nvSpPr>
@@ -5450,7 +5408,7 @@
       </p:sp>
       <p:sp>
         <p:nvSpPr>
-          <p:cNvPr id="86" name="Shape 82"/>
+          <p:cNvPr id="85" name="Shape 80"/>
           <p:cNvSpPr/>
           <p:nvPr/>
         </p:nvSpPr>
@@ -5475,7 +5433,7 @@
       </p:sp>
       <p:sp>
         <p:nvSpPr>
-          <p:cNvPr id="87" name="Shape 83"/>
+          <p:cNvPr id="86" name="Shape 81"/>
           <p:cNvSpPr/>
           <p:nvPr/>
         </p:nvSpPr>
@@ -5500,7 +5458,7 @@
       </p:sp>
       <p:sp>
         <p:nvSpPr>
-          <p:cNvPr id="88" name="Text 84"/>
+          <p:cNvPr id="87" name="Text 82"/>
           <p:cNvSpPr txBox="1"/>
           <p:nvPr/>
         </p:nvSpPr>
@@ -5542,7 +5500,7 @@
       </p:sp>
       <p:sp>
         <p:nvSpPr>
-          <p:cNvPr id="89" name="Shape 85"/>
+          <p:cNvPr id="88" name="Shape 83"/>
           <p:cNvSpPr/>
           <p:nvPr/>
         </p:nvSpPr>
@@ -5567,7 +5525,7 @@
       </p:sp>
       <p:sp>
         <p:nvSpPr>
-          <p:cNvPr id="90" name="Text 86"/>
+          <p:cNvPr id="89" name="Text 84"/>
           <p:cNvSpPr txBox="1"/>
           <p:nvPr/>
         </p:nvSpPr>
@@ -5626,7 +5584,7 @@
       </p:sp>
       <p:sp>
         <p:nvSpPr>
-          <p:cNvPr id="91" name="Shape 87"/>
+          <p:cNvPr id="90" name="Shape 85"/>
           <p:cNvSpPr/>
           <p:nvPr/>
         </p:nvSpPr>
@@ -5651,7 +5609,7 @@
       </p:sp>
       <p:sp>
         <p:nvSpPr>
-          <p:cNvPr id="92" name="Text 88"/>
+          <p:cNvPr id="91" name="Text 86"/>
           <p:cNvSpPr txBox="1"/>
           <p:nvPr/>
         </p:nvSpPr>
@@ -5710,7 +5668,7 @@
       </p:sp>
       <p:sp>
         <p:nvSpPr>
-          <p:cNvPr id="93" name="Shape 89"/>
+          <p:cNvPr id="92" name="Shape 87"/>
           <p:cNvSpPr/>
           <p:nvPr/>
         </p:nvSpPr>
@@ -5735,7 +5693,7 @@
       </p:sp>
       <p:sp>
         <p:nvSpPr>
-          <p:cNvPr id="94" name="Text 90"/>
+          <p:cNvPr id="93" name="Text 88"/>
           <p:cNvSpPr txBox="1"/>
           <p:nvPr/>
         </p:nvSpPr>
@@ -5794,7 +5752,7 @@
       </p:sp>
       <p:sp>
         <p:nvSpPr>
-          <p:cNvPr id="95" name="Shape 91"/>
+          <p:cNvPr id="94" name="Shape 89"/>
           <p:cNvSpPr/>
           <p:nvPr/>
         </p:nvSpPr>
@@ -5819,7 +5777,7 @@
       </p:sp>
       <p:sp>
         <p:nvSpPr>
-          <p:cNvPr id="96" name="Text 92"/>
+          <p:cNvPr id="95" name="Text 90"/>
           <p:cNvSpPr txBox="1"/>
           <p:nvPr/>
         </p:nvSpPr>
@@ -5878,7 +5836,7 @@
       </p:sp>
       <p:sp>
         <p:nvSpPr>
-          <p:cNvPr id="97" name="Shape 93"/>
+          <p:cNvPr id="96" name="Shape 91"/>
           <p:cNvSpPr/>
           <p:nvPr/>
         </p:nvSpPr>
@@ -5903,7 +5861,7 @@
       </p:sp>
       <p:sp>
         <p:nvSpPr>
-          <p:cNvPr id="98" name="Text 94"/>
+          <p:cNvPr id="97" name="Text 92"/>
           <p:cNvSpPr txBox="1"/>
           <p:nvPr/>
         </p:nvSpPr>
@@ -5962,7 +5920,7 @@
       </p:sp>
       <p:sp>
         <p:nvSpPr>
-          <p:cNvPr id="99" name="Shape 95"/>
+          <p:cNvPr id="98" name="Shape 93"/>
           <p:cNvSpPr/>
           <p:nvPr/>
         </p:nvSpPr>
@@ -5985,7 +5943,7 @@
       </p:sp>
       <p:sp>
         <p:nvSpPr>
-          <p:cNvPr id="100" name="Text 96"/>
+          <p:cNvPr id="99" name="Text 94"/>
           <p:cNvSpPr txBox="1"/>
           <p:nvPr/>
         </p:nvSpPr>
@@ -6120,81 +6078,39 @@
           </a:p>
         </p:txBody>
       </p:sp>
-      <p:sp>
-        <p:nvSpPr>
-          <p:cNvPr id="4" name="Shape 1"/>
+      <p:pic>
+        <p:nvPicPr>
+          <p:cNvPr id="4" name="Image 1" descr="../site/brand/jewell-wordmark.png">    </p:cNvPr>
+          <p:cNvPicPr>
+            <a:picLocks noChangeAspect="1"/>
+          </p:cNvPicPr>
+          <p:nvPr/>
+        </p:nvPicPr>
+        <p:blipFill>
+          <a:blip r:embed="rId2"/>
+          <a:stretch>
+            <a:fillRect/>
+          </a:stretch>
+        </p:blipFill>
+        <p:spPr>
+          <a:xfrm>
+            <a:off x="13915605" y="394290"/>
+            <a:ext cx="880302" cy="194400"/>
+          </a:xfrm>
+          <a:prstGeom prst="rect">
+            <a:avLst/>
+          </a:prstGeom>
+        </p:spPr>
+      </p:pic>
+      <p:sp>
+        <p:nvSpPr>
+          <p:cNvPr id="5" name="Shape 1"/>
           <p:cNvSpPr/>
           <p:nvPr/>
         </p:nvSpPr>
         <p:spPr>
           <a:xfrm>
-            <a:off x="13650938" y="365760"/>
-            <a:ext cx="1144969" cy="251460"/>
-          </a:xfrm>
-          <a:prstGeom prst="roundRect">
-            <a:avLst>
-              <a:gd name="adj" fmla="val 50000"/>
-            </a:avLst>
-          </a:prstGeom>
-          <a:solidFill>
-            <a:srgbClr val="0E171F"/>
-          </a:solidFill>
-          <a:ln w="9525">
-            <a:solidFill>
-              <a:srgbClr val="0E171F"/>
-            </a:solidFill>
-            <a:prstDash val="solid"/>
-          </a:ln>
-        </p:spPr>
-      </p:sp>
-      <p:sp>
-        <p:nvSpPr>
-          <p:cNvPr id="5" name="Text 2"/>
-          <p:cNvSpPr txBox="1"/>
-          <p:nvPr/>
-        </p:nvSpPr>
-        <p:spPr>
-          <a:xfrm>
-            <a:off x="13650938" y="365760"/>
-            <a:ext cx="1144969" cy="251460"/>
-          </a:xfrm>
-          <a:prstGeom prst="rect">
-            <a:avLst/>
-          </a:prstGeom>
-          <a:noFill/>
-          <a:ln/>
-        </p:spPr>
-        <p:txBody>
-          <a:bodyPr wrap="square" lIns="0" tIns="0" rIns="0" bIns="0" rtlCol="0" anchor="ctr"/>
-          <a:lstStyle/>
-          <a:p>
-            <a:pPr algn="ctr" indent="0" marL="0">
-              <a:buNone/>
-            </a:pPr>
-            <a:r>
-              <a:rPr lang="en-US" sz="650" b="1" spc="78" kern="0" dirty="0">
-                <a:solidFill>
-                  <a:srgbClr val="FFFFFF"/>
-                </a:solidFill>
-                <a:latin typeface="Poppins" pitchFamily="34" charset="0"/>
-                <a:ea typeface="Poppins" pitchFamily="34" charset="-122"/>
-                <a:cs typeface="Poppins" pitchFamily="34" charset="-120"/>
-              </a:rPr>
-              <a:t>JEWELL PROJECTS</a:t>
-            </a:r>
-            <a:endParaRPr lang="en-US" sz="650" dirty="0"/>
-          </a:p>
-        </p:txBody>
-      </p:sp>
-      <p:sp>
-        <p:nvSpPr>
-          <p:cNvPr id="6" name="Shape 3"/>
-          <p:cNvSpPr/>
-          <p:nvPr/>
-        </p:nvSpPr>
-        <p:spPr>
-          <a:xfrm>
-            <a:off x="12410462" y="365760"/>
+            <a:off x="12693129" y="365760"/>
             <a:ext cx="1150475" cy="251460"/>
           </a:xfrm>
           <a:prstGeom prst="roundRect">
@@ -6215,13 +6131,13 @@
       </p:sp>
       <p:sp>
         <p:nvSpPr>
-          <p:cNvPr id="7" name="Text 4"/>
+          <p:cNvPr id="6" name="Text 2"/>
           <p:cNvSpPr txBox="1"/>
           <p:nvPr/>
         </p:nvSpPr>
         <p:spPr>
           <a:xfrm>
-            <a:off x="12410462" y="365760"/>
+            <a:off x="12693129" y="365760"/>
             <a:ext cx="1150475" cy="251460"/>
           </a:xfrm>
           <a:prstGeom prst="rect">
@@ -6254,13 +6170,13 @@
       </p:sp>
       <p:sp>
         <p:nvSpPr>
-          <p:cNvPr id="8" name="Shape 5"/>
+          <p:cNvPr id="7" name="Shape 3"/>
           <p:cNvSpPr/>
           <p:nvPr/>
         </p:nvSpPr>
         <p:spPr>
           <a:xfrm>
-            <a:off x="11102419" y="365760"/>
+            <a:off x="11385086" y="365760"/>
             <a:ext cx="1218043" cy="251460"/>
           </a:xfrm>
           <a:prstGeom prst="roundRect">
@@ -6281,13 +6197,13 @@
       </p:sp>
       <p:sp>
         <p:nvSpPr>
-          <p:cNvPr id="9" name="Text 6"/>
+          <p:cNvPr id="8" name="Text 4"/>
           <p:cNvSpPr txBox="1"/>
           <p:nvPr/>
         </p:nvSpPr>
         <p:spPr>
           <a:xfrm>
-            <a:off x="11102419" y="365760"/>
+            <a:off x="11385086" y="365760"/>
             <a:ext cx="1218043" cy="251460"/>
           </a:xfrm>
           <a:prstGeom prst="rect">
@@ -6320,13 +6236,13 @@
       </p:sp>
       <p:sp>
         <p:nvSpPr>
-          <p:cNvPr id="10" name="Shape 7"/>
+          <p:cNvPr id="9" name="Shape 5"/>
           <p:cNvSpPr/>
           <p:nvPr/>
         </p:nvSpPr>
         <p:spPr>
           <a:xfrm>
-            <a:off x="10061373" y="365760"/>
+            <a:off x="10344040" y="365760"/>
             <a:ext cx="951046" cy="251460"/>
           </a:xfrm>
           <a:prstGeom prst="roundRect">
@@ -6339,7 +6255,7 @@
           </a:solidFill>
           <a:ln w="9525">
             <a:solidFill>
-              <a:srgbClr val="E3E7EC"/>
+              <a:srgbClr val="0066FF"/>
             </a:solidFill>
             <a:prstDash val="solid"/>
           </a:ln>
@@ -6347,13 +6263,13 @@
       </p:sp>
       <p:sp>
         <p:nvSpPr>
-          <p:cNvPr id="11" name="Text 8"/>
+          <p:cNvPr id="10" name="Text 6"/>
           <p:cNvSpPr txBox="1"/>
           <p:nvPr/>
         </p:nvSpPr>
         <p:spPr>
           <a:xfrm>
-            <a:off x="10061373" y="365760"/>
+            <a:off x="10344040" y="365760"/>
             <a:ext cx="951046" cy="251460"/>
           </a:xfrm>
           <a:prstGeom prst="rect">
@@ -6372,7 +6288,7 @@
             <a:r>
               <a:rPr lang="en-US" sz="650" b="1" spc="78" kern="0" dirty="0">
                 <a:solidFill>
-                  <a:srgbClr val="4A5565"/>
+                  <a:srgbClr val="0066FF"/>
                 </a:solidFill>
                 <a:latin typeface="Poppins" pitchFamily="34" charset="0"/>
                 <a:ea typeface="Poppins" pitchFamily="34" charset="-122"/>
@@ -6386,7 +6302,7 @@
       </p:sp>
       <p:sp>
         <p:nvSpPr>
-          <p:cNvPr id="12" name="Shape 9"/>
+          <p:cNvPr id="11" name="Shape 7"/>
           <p:cNvSpPr/>
           <p:nvPr/>
         </p:nvSpPr>
@@ -6409,7 +6325,7 @@
       </p:sp>
       <p:sp>
         <p:nvSpPr>
-          <p:cNvPr id="13" name="Shape 10"/>
+          <p:cNvPr id="12" name="Shape 8"/>
           <p:cNvSpPr/>
           <p:nvPr/>
         </p:nvSpPr>
@@ -6434,7 +6350,7 @@
       </p:sp>
       <p:sp>
         <p:nvSpPr>
-          <p:cNvPr id="14" name="Shape 11"/>
+          <p:cNvPr id="13" name="Shape 9"/>
           <p:cNvSpPr/>
           <p:nvPr/>
         </p:nvSpPr>
@@ -6459,7 +6375,7 @@
       </p:sp>
       <p:sp>
         <p:nvSpPr>
-          <p:cNvPr id="15" name="Text 12"/>
+          <p:cNvPr id="14" name="Text 10"/>
           <p:cNvSpPr txBox="1"/>
           <p:nvPr/>
         </p:nvSpPr>
@@ -6501,7 +6417,7 @@
       </p:sp>
       <p:sp>
         <p:nvSpPr>
-          <p:cNvPr id="16" name="Text 13"/>
+          <p:cNvPr id="15" name="Text 11"/>
           <p:cNvSpPr txBox="1"/>
           <p:nvPr/>
         </p:nvSpPr>
@@ -6543,7 +6459,7 @@
       </p:sp>
       <p:sp>
         <p:nvSpPr>
-          <p:cNvPr id="17" name="Text 14"/>
+          <p:cNvPr id="16" name="Text 12"/>
           <p:cNvSpPr txBox="1"/>
           <p:nvPr/>
         </p:nvSpPr>
@@ -6619,7 +6535,7 @@
       </p:sp>
       <p:sp>
         <p:nvSpPr>
-          <p:cNvPr id="18" name="Text 15"/>
+          <p:cNvPr id="17" name="Text 13"/>
           <p:cNvSpPr txBox="1"/>
           <p:nvPr/>
         </p:nvSpPr>
@@ -6678,7 +6594,7 @@
       </p:sp>
       <p:sp>
         <p:nvSpPr>
-          <p:cNvPr id="19" name="Text 16"/>
+          <p:cNvPr id="18" name="Text 14"/>
           <p:cNvSpPr txBox="1"/>
           <p:nvPr/>
         </p:nvSpPr>
@@ -6737,7 +6653,7 @@
       </p:sp>
       <p:sp>
         <p:nvSpPr>
-          <p:cNvPr id="20" name="Shape 17"/>
+          <p:cNvPr id="19" name="Shape 15"/>
           <p:cNvSpPr/>
           <p:nvPr/>
         </p:nvSpPr>
@@ -6760,7 +6676,7 @@
       </p:sp>
       <p:sp>
         <p:nvSpPr>
-          <p:cNvPr id="21" name="Text 18"/>
+          <p:cNvPr id="20" name="Text 16"/>
           <p:cNvSpPr txBox="1"/>
           <p:nvPr/>
         </p:nvSpPr>
@@ -6802,7 +6718,7 @@
       </p:sp>
       <p:sp>
         <p:nvSpPr>
-          <p:cNvPr id="22" name="Shape 19"/>
+          <p:cNvPr id="21" name="Shape 17"/>
           <p:cNvSpPr/>
           <p:nvPr/>
         </p:nvSpPr>
@@ -6827,7 +6743,7 @@
       </p:sp>
       <p:sp>
         <p:nvSpPr>
-          <p:cNvPr id="23" name="Text 20"/>
+          <p:cNvPr id="22" name="Text 18"/>
           <p:cNvSpPr txBox="1"/>
           <p:nvPr/>
         </p:nvSpPr>
@@ -7773,7 +7689,7 @@
       </p:graphicFrame>
       <p:sp>
         <p:nvSpPr>
-          <p:cNvPr id="25" name="Shape 21"/>
+          <p:cNvPr id="24" name="Shape 19"/>
           <p:cNvSpPr/>
           <p:nvPr/>
         </p:nvSpPr>
@@ -7796,7 +7712,7 @@
       </p:sp>
       <p:sp>
         <p:nvSpPr>
-          <p:cNvPr id="26" name="Text 22"/>
+          <p:cNvPr id="25" name="Text 20"/>
           <p:cNvSpPr txBox="1"/>
           <p:nvPr/>
         </p:nvSpPr>
@@ -7838,7 +7754,7 @@
       </p:sp>
       <p:sp>
         <p:nvSpPr>
-          <p:cNvPr id="27" name="Shape 23"/>
+          <p:cNvPr id="26" name="Shape 21"/>
           <p:cNvSpPr/>
           <p:nvPr/>
         </p:nvSpPr>
@@ -7863,7 +7779,7 @@
       </p:sp>
       <p:sp>
         <p:nvSpPr>
-          <p:cNvPr id="28" name="Text 24"/>
+          <p:cNvPr id="27" name="Text 22"/>
           <p:cNvSpPr txBox="1"/>
           <p:nvPr/>
         </p:nvSpPr>
@@ -7905,7 +7821,7 @@
       </p:sp>
       <p:sp>
         <p:nvSpPr>
-          <p:cNvPr id="29" name="Shape 25"/>
+          <p:cNvPr id="28" name="Shape 23"/>
           <p:cNvSpPr/>
           <p:nvPr/>
         </p:nvSpPr>
@@ -7930,7 +7846,7 @@
       </p:sp>
       <p:sp>
         <p:nvSpPr>
-          <p:cNvPr id="30" name="Text 26"/>
+          <p:cNvPr id="29" name="Text 24"/>
           <p:cNvSpPr txBox="1"/>
           <p:nvPr/>
         </p:nvSpPr>
@@ -7972,7 +7888,7 @@
       </p:sp>
       <p:sp>
         <p:nvSpPr>
-          <p:cNvPr id="31" name="Text 27"/>
+          <p:cNvPr id="30" name="Text 25"/>
           <p:cNvSpPr txBox="1"/>
           <p:nvPr/>
         </p:nvSpPr>
@@ -8014,7 +7930,7 @@
       </p:sp>
       <p:sp>
         <p:nvSpPr>
-          <p:cNvPr id="32" name="Shape 28"/>
+          <p:cNvPr id="31" name="Shape 26"/>
           <p:cNvSpPr/>
           <p:nvPr/>
         </p:nvSpPr>
@@ -8039,7 +7955,7 @@
       </p:sp>
       <p:sp>
         <p:nvSpPr>
-          <p:cNvPr id="33" name="Text 29"/>
+          <p:cNvPr id="32" name="Text 27"/>
           <p:cNvSpPr txBox="1"/>
           <p:nvPr/>
         </p:nvSpPr>
@@ -8081,7 +7997,7 @@
       </p:sp>
       <p:sp>
         <p:nvSpPr>
-          <p:cNvPr id="34" name="Text 30"/>
+          <p:cNvPr id="33" name="Text 28"/>
           <p:cNvSpPr txBox="1"/>
           <p:nvPr/>
         </p:nvSpPr>
@@ -8123,7 +8039,7 @@
       </p:sp>
       <p:sp>
         <p:nvSpPr>
-          <p:cNvPr id="35" name="Shape 31"/>
+          <p:cNvPr id="34" name="Shape 29"/>
           <p:cNvSpPr/>
           <p:nvPr/>
         </p:nvSpPr>
@@ -8148,7 +8064,7 @@
       </p:sp>
       <p:sp>
         <p:nvSpPr>
-          <p:cNvPr id="36" name="Text 32"/>
+          <p:cNvPr id="35" name="Text 30"/>
           <p:cNvSpPr txBox="1"/>
           <p:nvPr/>
         </p:nvSpPr>
@@ -8190,7 +8106,7 @@
       </p:sp>
       <p:sp>
         <p:nvSpPr>
-          <p:cNvPr id="37" name="Text 33"/>
+          <p:cNvPr id="36" name="Text 31"/>
           <p:cNvSpPr txBox="1"/>
           <p:nvPr/>
         </p:nvSpPr>
@@ -8232,7 +8148,7 @@
       </p:sp>
       <p:sp>
         <p:nvSpPr>
-          <p:cNvPr id="38" name="Text 34"/>
+          <p:cNvPr id="37" name="Text 32"/>
           <p:cNvSpPr txBox="1"/>
           <p:nvPr/>
         </p:nvSpPr>
@@ -8274,7 +8190,7 @@
       </p:sp>
       <p:sp>
         <p:nvSpPr>
-          <p:cNvPr id="39" name="Text 35"/>
+          <p:cNvPr id="38" name="Text 33"/>
           <p:cNvSpPr txBox="1"/>
           <p:nvPr/>
         </p:nvSpPr>
@@ -8333,7 +8249,7 @@
       </p:sp>
       <p:sp>
         <p:nvSpPr>
-          <p:cNvPr id="40" name="Shape 36"/>
+          <p:cNvPr id="39" name="Shape 34"/>
           <p:cNvSpPr/>
           <p:nvPr/>
         </p:nvSpPr>
@@ -8356,7 +8272,7 @@
       </p:sp>
       <p:sp>
         <p:nvSpPr>
-          <p:cNvPr id="41" name="Text 37"/>
+          <p:cNvPr id="40" name="Text 35"/>
           <p:cNvSpPr txBox="1"/>
           <p:nvPr/>
         </p:nvSpPr>
@@ -8398,7 +8314,7 @@
       </p:sp>
       <p:sp>
         <p:nvSpPr>
-          <p:cNvPr id="42" name="Shape 38"/>
+          <p:cNvPr id="41" name="Shape 36"/>
           <p:cNvSpPr/>
           <p:nvPr/>
         </p:nvSpPr>
@@ -8423,7 +8339,7 @@
       </p:sp>
       <p:sp>
         <p:nvSpPr>
-          <p:cNvPr id="43" name="Text 39"/>
+          <p:cNvPr id="42" name="Text 37"/>
           <p:cNvSpPr txBox="1"/>
           <p:nvPr/>
         </p:nvSpPr>
@@ -8465,7 +8381,7 @@
       </p:sp>
       <p:sp>
         <p:nvSpPr>
-          <p:cNvPr id="44" name="Text 40"/>
+          <p:cNvPr id="43" name="Text 38"/>
           <p:cNvSpPr txBox="1"/>
           <p:nvPr/>
         </p:nvSpPr>
@@ -8524,7 +8440,7 @@
       </p:sp>
       <p:sp>
         <p:nvSpPr>
-          <p:cNvPr id="45" name="Text 41"/>
+          <p:cNvPr id="44" name="Text 39"/>
           <p:cNvSpPr txBox="1"/>
           <p:nvPr/>
         </p:nvSpPr>
@@ -8583,7 +8499,7 @@
       </p:sp>
       <p:sp>
         <p:nvSpPr>
-          <p:cNvPr id="46" name="Text 42"/>
+          <p:cNvPr id="45" name="Text 40"/>
           <p:cNvSpPr txBox="1"/>
           <p:nvPr/>
         </p:nvSpPr>
@@ -8642,7 +8558,7 @@
       </p:sp>
       <p:sp>
         <p:nvSpPr>
-          <p:cNvPr id="47" name="Text 43"/>
+          <p:cNvPr id="46" name="Text 41"/>
           <p:cNvSpPr txBox="1"/>
           <p:nvPr/>
         </p:nvSpPr>
@@ -8701,7 +8617,7 @@
       </p:sp>
       <p:sp>
         <p:nvSpPr>
-          <p:cNvPr id="48" name="Text 44"/>
+          <p:cNvPr id="47" name="Text 42"/>
           <p:cNvSpPr txBox="1"/>
           <p:nvPr/>
         </p:nvSpPr>
@@ -8760,7 +8676,7 @@
       </p:sp>
       <p:sp>
         <p:nvSpPr>
-          <p:cNvPr id="49" name="Shape 45"/>
+          <p:cNvPr id="48" name="Shape 43"/>
           <p:cNvSpPr/>
           <p:nvPr/>
         </p:nvSpPr>
@@ -8783,7 +8699,7 @@
       </p:sp>
       <p:sp>
         <p:nvSpPr>
-          <p:cNvPr id="50" name="Text 46"/>
+          <p:cNvPr id="49" name="Text 44"/>
           <p:cNvSpPr txBox="1"/>
           <p:nvPr/>
         </p:nvSpPr>
@@ -8825,7 +8741,7 @@
       </p:sp>
       <p:sp>
         <p:nvSpPr>
-          <p:cNvPr id="51" name="Shape 47"/>
+          <p:cNvPr id="50" name="Shape 45"/>
           <p:cNvSpPr/>
           <p:nvPr/>
         </p:nvSpPr>
@@ -8850,7 +8766,7 @@
       </p:sp>
       <p:sp>
         <p:nvSpPr>
-          <p:cNvPr id="52" name="Text 48"/>
+          <p:cNvPr id="51" name="Text 46"/>
           <p:cNvSpPr txBox="1"/>
           <p:nvPr/>
         </p:nvSpPr>
@@ -8892,7 +8808,7 @@
       </p:sp>
       <p:sp>
         <p:nvSpPr>
-          <p:cNvPr id="53" name="Text 49"/>
+          <p:cNvPr id="52" name="Text 47"/>
           <p:cNvSpPr txBox="1"/>
           <p:nvPr/>
         </p:nvSpPr>
@@ -8934,7 +8850,7 @@
       </p:sp>
       <p:sp>
         <p:nvSpPr>
-          <p:cNvPr id="54" name="Text 50"/>
+          <p:cNvPr id="53" name="Text 48"/>
           <p:cNvSpPr txBox="1"/>
           <p:nvPr/>
         </p:nvSpPr>
@@ -8993,7 +8909,7 @@
       </p:sp>
       <p:sp>
         <p:nvSpPr>
-          <p:cNvPr id="55" name="Text 51"/>
+          <p:cNvPr id="54" name="Text 49"/>
           <p:cNvSpPr txBox="1"/>
           <p:nvPr/>
         </p:nvSpPr>
@@ -9052,7 +8968,7 @@
       </p:sp>
       <p:sp>
         <p:nvSpPr>
-          <p:cNvPr id="56" name="Text 52"/>
+          <p:cNvPr id="55" name="Text 50"/>
           <p:cNvSpPr txBox="1"/>
           <p:nvPr/>
         </p:nvSpPr>
@@ -9111,7 +9027,7 @@
       </p:sp>
       <p:sp>
         <p:nvSpPr>
-          <p:cNvPr id="57" name="Shape 53"/>
+          <p:cNvPr id="56" name="Shape 51"/>
           <p:cNvSpPr/>
           <p:nvPr/>
         </p:nvSpPr>
@@ -9134,7 +9050,7 @@
       </p:sp>
       <p:sp>
         <p:nvSpPr>
-          <p:cNvPr id="58" name="Text 54"/>
+          <p:cNvPr id="57" name="Text 52"/>
           <p:cNvSpPr txBox="1"/>
           <p:nvPr/>
         </p:nvSpPr>
@@ -9176,7 +9092,7 @@
       </p:sp>
       <p:sp>
         <p:nvSpPr>
-          <p:cNvPr id="59" name="Shape 55"/>
+          <p:cNvPr id="58" name="Shape 53"/>
           <p:cNvSpPr/>
           <p:nvPr/>
         </p:nvSpPr>
@@ -9201,7 +9117,7 @@
       </p:sp>
       <p:sp>
         <p:nvSpPr>
-          <p:cNvPr id="60" name="Text 56"/>
+          <p:cNvPr id="59" name="Text 54"/>
           <p:cNvSpPr txBox="1"/>
           <p:nvPr/>
         </p:nvSpPr>
@@ -9243,7 +9159,7 @@
       </p:sp>
       <p:sp>
         <p:nvSpPr>
-          <p:cNvPr id="61" name="Shape 57"/>
+          <p:cNvPr id="60" name="Shape 55"/>
           <p:cNvSpPr/>
           <p:nvPr/>
         </p:nvSpPr>
@@ -9268,7 +9184,7 @@
       </p:sp>
       <p:sp>
         <p:nvSpPr>
-          <p:cNvPr id="62" name="Text 58"/>
+          <p:cNvPr id="61" name="Text 56"/>
           <p:cNvSpPr txBox="1"/>
           <p:nvPr/>
         </p:nvSpPr>
@@ -9327,7 +9243,7 @@
       </p:sp>
       <p:sp>
         <p:nvSpPr>
-          <p:cNvPr id="63" name="Shape 59"/>
+          <p:cNvPr id="62" name="Shape 57"/>
           <p:cNvSpPr/>
           <p:nvPr/>
         </p:nvSpPr>
@@ -9352,7 +9268,7 @@
       </p:sp>
       <p:sp>
         <p:nvSpPr>
-          <p:cNvPr id="64" name="Text 60"/>
+          <p:cNvPr id="63" name="Text 58"/>
           <p:cNvSpPr txBox="1"/>
           <p:nvPr/>
         </p:nvSpPr>
@@ -9411,7 +9327,7 @@
       </p:sp>
       <p:sp>
         <p:nvSpPr>
-          <p:cNvPr id="65" name="Shape 61"/>
+          <p:cNvPr id="64" name="Shape 59"/>
           <p:cNvSpPr/>
           <p:nvPr/>
         </p:nvSpPr>
@@ -9436,7 +9352,7 @@
       </p:sp>
       <p:sp>
         <p:nvSpPr>
-          <p:cNvPr id="66" name="Text 62"/>
+          <p:cNvPr id="65" name="Text 60"/>
           <p:cNvSpPr txBox="1"/>
           <p:nvPr/>
         </p:nvSpPr>
@@ -9495,7 +9411,7 @@
       </p:sp>
       <p:sp>
         <p:nvSpPr>
-          <p:cNvPr id="67" name="Shape 63"/>
+          <p:cNvPr id="66" name="Shape 61"/>
           <p:cNvSpPr/>
           <p:nvPr/>
         </p:nvSpPr>
@@ -9520,7 +9436,7 @@
       </p:sp>
       <p:sp>
         <p:nvSpPr>
-          <p:cNvPr id="68" name="Text 64"/>
+          <p:cNvPr id="67" name="Text 62"/>
           <p:cNvSpPr txBox="1"/>
           <p:nvPr/>
         </p:nvSpPr>
@@ -9579,7 +9495,7 @@
       </p:sp>
       <p:sp>
         <p:nvSpPr>
-          <p:cNvPr id="69" name="Shape 65"/>
+          <p:cNvPr id="68" name="Shape 63"/>
           <p:cNvSpPr/>
           <p:nvPr/>
         </p:nvSpPr>
@@ -9604,7 +9520,7 @@
       </p:sp>
       <p:sp>
         <p:nvSpPr>
-          <p:cNvPr id="70" name="Text 66"/>
+          <p:cNvPr id="69" name="Text 64"/>
           <p:cNvSpPr txBox="1"/>
           <p:nvPr/>
         </p:nvSpPr>
@@ -9663,7 +9579,7 @@
       </p:sp>
       <p:sp>
         <p:nvSpPr>
-          <p:cNvPr id="71" name="Shape 67"/>
+          <p:cNvPr id="70" name="Shape 65"/>
           <p:cNvSpPr/>
           <p:nvPr/>
         </p:nvSpPr>
@@ -9688,7 +9604,7 @@
       </p:sp>
       <p:sp>
         <p:nvSpPr>
-          <p:cNvPr id="72" name="Text 68"/>
+          <p:cNvPr id="71" name="Text 66"/>
           <p:cNvSpPr txBox="1"/>
           <p:nvPr/>
         </p:nvSpPr>
@@ -9730,7 +9646,7 @@
       </p:sp>
       <p:sp>
         <p:nvSpPr>
-          <p:cNvPr id="73" name="Shape 69"/>
+          <p:cNvPr id="72" name="Shape 67"/>
           <p:cNvSpPr/>
           <p:nvPr/>
         </p:nvSpPr>
@@ -9755,7 +9671,7 @@
       </p:sp>
       <p:sp>
         <p:nvSpPr>
-          <p:cNvPr id="74" name="Text 70"/>
+          <p:cNvPr id="73" name="Text 68"/>
           <p:cNvSpPr txBox="1"/>
           <p:nvPr/>
         </p:nvSpPr>
@@ -9814,7 +9730,7 @@
       </p:sp>
       <p:sp>
         <p:nvSpPr>
-          <p:cNvPr id="75" name="Shape 71"/>
+          <p:cNvPr id="74" name="Shape 69"/>
           <p:cNvSpPr/>
           <p:nvPr/>
         </p:nvSpPr>
@@ -9839,7 +9755,7 @@
       </p:sp>
       <p:sp>
         <p:nvSpPr>
-          <p:cNvPr id="76" name="Text 72"/>
+          <p:cNvPr id="75" name="Text 70"/>
           <p:cNvSpPr txBox="1"/>
           <p:nvPr/>
         </p:nvSpPr>
@@ -9898,7 +9814,7 @@
       </p:sp>
       <p:sp>
         <p:nvSpPr>
-          <p:cNvPr id="77" name="Shape 73"/>
+          <p:cNvPr id="76" name="Shape 71"/>
           <p:cNvSpPr/>
           <p:nvPr/>
         </p:nvSpPr>
@@ -9923,7 +9839,7 @@
       </p:sp>
       <p:sp>
         <p:nvSpPr>
-          <p:cNvPr id="78" name="Text 74"/>
+          <p:cNvPr id="77" name="Text 72"/>
           <p:cNvSpPr txBox="1"/>
           <p:nvPr/>
         </p:nvSpPr>
@@ -9982,7 +9898,7 @@
       </p:sp>
       <p:sp>
         <p:nvSpPr>
-          <p:cNvPr id="79" name="Shape 75"/>
+          <p:cNvPr id="78" name="Shape 73"/>
           <p:cNvSpPr/>
           <p:nvPr/>
         </p:nvSpPr>
@@ -10007,7 +9923,7 @@
       </p:sp>
       <p:sp>
         <p:nvSpPr>
-          <p:cNvPr id="80" name="Text 76"/>
+          <p:cNvPr id="79" name="Text 74"/>
           <p:cNvSpPr txBox="1"/>
           <p:nvPr/>
         </p:nvSpPr>
@@ -10066,7 +9982,7 @@
       </p:sp>
       <p:sp>
         <p:nvSpPr>
-          <p:cNvPr id="81" name="Shape 77"/>
+          <p:cNvPr id="80" name="Shape 75"/>
           <p:cNvSpPr/>
           <p:nvPr/>
         </p:nvSpPr>
@@ -10089,7 +10005,7 @@
       </p:sp>
       <p:sp>
         <p:nvSpPr>
-          <p:cNvPr id="82" name="Text 78"/>
+          <p:cNvPr id="81" name="Text 76"/>
           <p:cNvSpPr txBox="1"/>
           <p:nvPr/>
         </p:nvSpPr>
@@ -10224,81 +10140,39 @@
           </a:p>
         </p:txBody>
       </p:sp>
-      <p:sp>
-        <p:nvSpPr>
-          <p:cNvPr id="4" name="Shape 1"/>
+      <p:pic>
+        <p:nvPicPr>
+          <p:cNvPr id="4" name="Image 1" descr="../site/brand/jewell-wordmark.png">    </p:cNvPr>
+          <p:cNvPicPr>
+            <a:picLocks noChangeAspect="1"/>
+          </p:cNvPicPr>
+          <p:nvPr/>
+        </p:nvPicPr>
+        <p:blipFill>
+          <a:blip r:embed="rId2"/>
+          <a:stretch>
+            <a:fillRect/>
+          </a:stretch>
+        </p:blipFill>
+        <p:spPr>
+          <a:xfrm>
+            <a:off x="13915605" y="394290"/>
+            <a:ext cx="880302" cy="194400"/>
+          </a:xfrm>
+          <a:prstGeom prst="rect">
+            <a:avLst/>
+          </a:prstGeom>
+        </p:spPr>
+      </p:pic>
+      <p:sp>
+        <p:nvSpPr>
+          <p:cNvPr id="5" name="Shape 1"/>
           <p:cNvSpPr/>
           <p:nvPr/>
         </p:nvSpPr>
         <p:spPr>
           <a:xfrm>
-            <a:off x="13650938" y="365760"/>
-            <a:ext cx="1144969" cy="251460"/>
-          </a:xfrm>
-          <a:prstGeom prst="roundRect">
-            <a:avLst>
-              <a:gd name="adj" fmla="val 50000"/>
-            </a:avLst>
-          </a:prstGeom>
-          <a:solidFill>
-            <a:srgbClr val="0E171F"/>
-          </a:solidFill>
-          <a:ln w="9525">
-            <a:solidFill>
-              <a:srgbClr val="0E171F"/>
-            </a:solidFill>
-            <a:prstDash val="solid"/>
-          </a:ln>
-        </p:spPr>
-      </p:sp>
-      <p:sp>
-        <p:nvSpPr>
-          <p:cNvPr id="5" name="Text 2"/>
-          <p:cNvSpPr txBox="1"/>
-          <p:nvPr/>
-        </p:nvSpPr>
-        <p:spPr>
-          <a:xfrm>
-            <a:off x="13650938" y="365760"/>
-            <a:ext cx="1144969" cy="251460"/>
-          </a:xfrm>
-          <a:prstGeom prst="rect">
-            <a:avLst/>
-          </a:prstGeom>
-          <a:noFill/>
-          <a:ln/>
-        </p:spPr>
-        <p:txBody>
-          <a:bodyPr wrap="square" lIns="0" tIns="0" rIns="0" bIns="0" rtlCol="0" anchor="ctr"/>
-          <a:lstStyle/>
-          <a:p>
-            <a:pPr algn="ctr" indent="0" marL="0">
-              <a:buNone/>
-            </a:pPr>
-            <a:r>
-              <a:rPr lang="en-US" sz="650" b="1" spc="78" kern="0" dirty="0">
-                <a:solidFill>
-                  <a:srgbClr val="FFFFFF"/>
-                </a:solidFill>
-                <a:latin typeface="Poppins" pitchFamily="34" charset="0"/>
-                <a:ea typeface="Poppins" pitchFamily="34" charset="-122"/>
-                <a:cs typeface="Poppins" pitchFamily="34" charset="-120"/>
-              </a:rPr>
-              <a:t>JEWELL PROJECTS</a:t>
-            </a:r>
-            <a:endParaRPr lang="en-US" sz="650" dirty="0"/>
-          </a:p>
-        </p:txBody>
-      </p:sp>
-      <p:sp>
-        <p:nvSpPr>
-          <p:cNvPr id="6" name="Shape 3"/>
-          <p:cNvSpPr/>
-          <p:nvPr/>
-        </p:nvSpPr>
-        <p:spPr>
-          <a:xfrm>
-            <a:off x="12410462" y="365760"/>
+            <a:off x="12693129" y="365760"/>
             <a:ext cx="1150475" cy="251460"/>
           </a:xfrm>
           <a:prstGeom prst="roundRect">
@@ -10319,13 +10193,13 @@
       </p:sp>
       <p:sp>
         <p:nvSpPr>
-          <p:cNvPr id="7" name="Text 4"/>
+          <p:cNvPr id="6" name="Text 2"/>
           <p:cNvSpPr txBox="1"/>
           <p:nvPr/>
         </p:nvSpPr>
         <p:spPr>
           <a:xfrm>
-            <a:off x="12410462" y="365760"/>
+            <a:off x="12693129" y="365760"/>
             <a:ext cx="1150475" cy="251460"/>
           </a:xfrm>
           <a:prstGeom prst="rect">
@@ -10358,13 +10232,13 @@
       </p:sp>
       <p:sp>
         <p:nvSpPr>
-          <p:cNvPr id="8" name="Shape 5"/>
+          <p:cNvPr id="7" name="Shape 3"/>
           <p:cNvSpPr/>
           <p:nvPr/>
         </p:nvSpPr>
         <p:spPr>
           <a:xfrm>
-            <a:off x="11102419" y="365760"/>
+            <a:off x="11385086" y="365760"/>
             <a:ext cx="1218043" cy="251460"/>
           </a:xfrm>
           <a:prstGeom prst="roundRect">
@@ -10385,13 +10259,13 @@
       </p:sp>
       <p:sp>
         <p:nvSpPr>
-          <p:cNvPr id="9" name="Text 6"/>
+          <p:cNvPr id="8" name="Text 4"/>
           <p:cNvSpPr txBox="1"/>
           <p:nvPr/>
         </p:nvSpPr>
         <p:spPr>
           <a:xfrm>
-            <a:off x="11102419" y="365760"/>
+            <a:off x="11385086" y="365760"/>
             <a:ext cx="1218043" cy="251460"/>
           </a:xfrm>
           <a:prstGeom prst="rect">
@@ -10424,13 +10298,13 @@
       </p:sp>
       <p:sp>
         <p:nvSpPr>
-          <p:cNvPr id="10" name="Shape 7"/>
+          <p:cNvPr id="9" name="Shape 5"/>
           <p:cNvSpPr/>
           <p:nvPr/>
         </p:nvSpPr>
         <p:spPr>
           <a:xfrm>
-            <a:off x="10045300" y="365760"/>
+            <a:off x="10327967" y="365760"/>
             <a:ext cx="967119" cy="251460"/>
           </a:xfrm>
           <a:prstGeom prst="roundRect">
@@ -10443,7 +10317,7 @@
           </a:solidFill>
           <a:ln w="9525">
             <a:solidFill>
-              <a:srgbClr val="E3E7EC"/>
+              <a:srgbClr val="0066FF"/>
             </a:solidFill>
             <a:prstDash val="solid"/>
           </a:ln>
@@ -10451,13 +10325,13 @@
       </p:sp>
       <p:sp>
         <p:nvSpPr>
-          <p:cNvPr id="11" name="Text 8"/>
+          <p:cNvPr id="10" name="Text 6"/>
           <p:cNvSpPr txBox="1"/>
           <p:nvPr/>
         </p:nvSpPr>
         <p:spPr>
           <a:xfrm>
-            <a:off x="10045300" y="365760"/>
+            <a:off x="10327967" y="365760"/>
             <a:ext cx="967119" cy="251460"/>
           </a:xfrm>
           <a:prstGeom prst="rect">
@@ -10476,7 +10350,7 @@
             <a:r>
               <a:rPr lang="en-US" sz="650" b="1" spc="78" kern="0" dirty="0">
                 <a:solidFill>
-                  <a:srgbClr val="4A5565"/>
+                  <a:srgbClr val="0066FF"/>
                 </a:solidFill>
                 <a:latin typeface="Poppins" pitchFamily="34" charset="0"/>
                 <a:ea typeface="Poppins" pitchFamily="34" charset="-122"/>
@@ -10490,7 +10364,7 @@
       </p:sp>
       <p:sp>
         <p:nvSpPr>
-          <p:cNvPr id="12" name="Shape 9"/>
+          <p:cNvPr id="11" name="Shape 7"/>
           <p:cNvSpPr/>
           <p:nvPr/>
         </p:nvSpPr>
@@ -10513,7 +10387,7 @@
       </p:sp>
       <p:sp>
         <p:nvSpPr>
-          <p:cNvPr id="13" name="Shape 10"/>
+          <p:cNvPr id="12" name="Shape 8"/>
           <p:cNvSpPr/>
           <p:nvPr/>
         </p:nvSpPr>
@@ -10538,7 +10412,7 @@
       </p:sp>
       <p:sp>
         <p:nvSpPr>
-          <p:cNvPr id="14" name="Shape 11"/>
+          <p:cNvPr id="13" name="Shape 9"/>
           <p:cNvSpPr/>
           <p:nvPr/>
         </p:nvSpPr>
@@ -10563,7 +10437,7 @@
       </p:sp>
       <p:sp>
         <p:nvSpPr>
-          <p:cNvPr id="15" name="Text 12"/>
+          <p:cNvPr id="14" name="Text 10"/>
           <p:cNvSpPr txBox="1"/>
           <p:nvPr/>
         </p:nvSpPr>
@@ -10605,7 +10479,7 @@
       </p:sp>
       <p:sp>
         <p:nvSpPr>
-          <p:cNvPr id="16" name="Text 13"/>
+          <p:cNvPr id="15" name="Text 11"/>
           <p:cNvSpPr txBox="1"/>
           <p:nvPr/>
         </p:nvSpPr>
@@ -10647,7 +10521,7 @@
       </p:sp>
       <p:sp>
         <p:nvSpPr>
-          <p:cNvPr id="17" name="Text 14"/>
+          <p:cNvPr id="16" name="Text 12"/>
           <p:cNvSpPr txBox="1"/>
           <p:nvPr/>
         </p:nvSpPr>
@@ -10689,7 +10563,7 @@
       </p:sp>
       <p:sp>
         <p:nvSpPr>
-          <p:cNvPr id="18" name="Text 15"/>
+          <p:cNvPr id="17" name="Text 13"/>
           <p:cNvSpPr txBox="1"/>
           <p:nvPr/>
         </p:nvSpPr>
@@ -10731,7 +10605,7 @@
       </p:sp>
       <p:sp>
         <p:nvSpPr>
-          <p:cNvPr id="19" name="Text 16"/>
+          <p:cNvPr id="18" name="Text 14"/>
           <p:cNvSpPr txBox="1"/>
           <p:nvPr/>
         </p:nvSpPr>
@@ -10790,7 +10664,7 @@
       </p:sp>
       <p:sp>
         <p:nvSpPr>
-          <p:cNvPr id="20" name="Shape 17"/>
+          <p:cNvPr id="19" name="Shape 15"/>
           <p:cNvSpPr/>
           <p:nvPr/>
         </p:nvSpPr>
@@ -10813,7 +10687,7 @@
       </p:sp>
       <p:sp>
         <p:nvSpPr>
-          <p:cNvPr id="21" name="Text 18"/>
+          <p:cNvPr id="20" name="Text 16"/>
           <p:cNvSpPr txBox="1"/>
           <p:nvPr/>
         </p:nvSpPr>
@@ -10855,7 +10729,7 @@
       </p:sp>
       <p:sp>
         <p:nvSpPr>
-          <p:cNvPr id="22" name="Shape 19"/>
+          <p:cNvPr id="21" name="Shape 17"/>
           <p:cNvSpPr/>
           <p:nvPr/>
         </p:nvSpPr>
@@ -10880,7 +10754,7 @@
       </p:sp>
       <p:sp>
         <p:nvSpPr>
-          <p:cNvPr id="23" name="Text 20"/>
+          <p:cNvPr id="22" name="Text 18"/>
           <p:cNvSpPr txBox="1"/>
           <p:nvPr/>
         </p:nvSpPr>
@@ -10922,7 +10796,7 @@
       </p:sp>
       <p:sp>
         <p:nvSpPr>
-          <p:cNvPr id="24" name="Text 21"/>
+          <p:cNvPr id="23" name="Text 19"/>
           <p:cNvSpPr txBox="1"/>
           <p:nvPr/>
         </p:nvSpPr>
@@ -10964,7 +10838,7 @@
       </p:sp>
       <p:sp>
         <p:nvSpPr>
-          <p:cNvPr id="25" name="Text 22"/>
+          <p:cNvPr id="24" name="Text 20"/>
           <p:cNvSpPr txBox="1"/>
           <p:nvPr/>
         </p:nvSpPr>
@@ -11040,7 +10914,7 @@
       </p:sp>
       <p:sp>
         <p:nvSpPr>
-          <p:cNvPr id="26" name="Text 23"/>
+          <p:cNvPr id="25" name="Text 21"/>
           <p:cNvSpPr txBox="1"/>
           <p:nvPr/>
         </p:nvSpPr>
@@ -11099,7 +10973,7 @@
       </p:sp>
       <p:sp>
         <p:nvSpPr>
-          <p:cNvPr id="27" name="Text 24"/>
+          <p:cNvPr id="26" name="Text 22"/>
           <p:cNvSpPr txBox="1"/>
           <p:nvPr/>
         </p:nvSpPr>
@@ -11158,7 +11032,7 @@
       </p:sp>
       <p:sp>
         <p:nvSpPr>
-          <p:cNvPr id="28" name="Shape 25"/>
+          <p:cNvPr id="27" name="Shape 23"/>
           <p:cNvSpPr/>
           <p:nvPr/>
         </p:nvSpPr>
@@ -11181,7 +11055,7 @@
       </p:sp>
       <p:sp>
         <p:nvSpPr>
-          <p:cNvPr id="29" name="Text 26"/>
+          <p:cNvPr id="28" name="Text 24"/>
           <p:cNvSpPr txBox="1"/>
           <p:nvPr/>
         </p:nvSpPr>
@@ -11223,7 +11097,7 @@
       </p:sp>
       <p:sp>
         <p:nvSpPr>
-          <p:cNvPr id="30" name="Shape 27"/>
+          <p:cNvPr id="29" name="Shape 25"/>
           <p:cNvSpPr/>
           <p:nvPr/>
         </p:nvSpPr>
@@ -11248,7 +11122,7 @@
       </p:sp>
       <p:sp>
         <p:nvSpPr>
-          <p:cNvPr id="31" name="Text 28"/>
+          <p:cNvPr id="30" name="Text 26"/>
           <p:cNvSpPr txBox="1"/>
           <p:nvPr/>
         </p:nvSpPr>
@@ -11290,7 +11164,7 @@
       </p:sp>
       <p:sp>
         <p:nvSpPr>
-          <p:cNvPr id="32" name="Text 29"/>
+          <p:cNvPr id="31" name="Text 27"/>
           <p:cNvSpPr txBox="1"/>
           <p:nvPr/>
         </p:nvSpPr>
@@ -11349,7 +11223,7 @@
       </p:sp>
       <p:sp>
         <p:nvSpPr>
-          <p:cNvPr id="33" name="Text 30"/>
+          <p:cNvPr id="32" name="Text 28"/>
           <p:cNvSpPr txBox="1"/>
           <p:nvPr/>
         </p:nvSpPr>
@@ -11408,7 +11282,7 @@
       </p:sp>
       <p:sp>
         <p:nvSpPr>
-          <p:cNvPr id="34" name="Text 31"/>
+          <p:cNvPr id="33" name="Text 29"/>
           <p:cNvSpPr txBox="1"/>
           <p:nvPr/>
         </p:nvSpPr>
@@ -11467,7 +11341,7 @@
       </p:sp>
       <p:sp>
         <p:nvSpPr>
-          <p:cNvPr id="35" name="Shape 32"/>
+          <p:cNvPr id="34" name="Shape 30"/>
           <p:cNvSpPr/>
           <p:nvPr/>
         </p:nvSpPr>
@@ -11490,7 +11364,7 @@
       </p:sp>
       <p:sp>
         <p:nvSpPr>
-          <p:cNvPr id="36" name="Text 33"/>
+          <p:cNvPr id="35" name="Text 31"/>
           <p:cNvSpPr txBox="1"/>
           <p:nvPr/>
         </p:nvSpPr>
@@ -11532,7 +11406,7 @@
       </p:sp>
       <p:sp>
         <p:nvSpPr>
-          <p:cNvPr id="37" name="Shape 34"/>
+          <p:cNvPr id="36" name="Shape 32"/>
           <p:cNvSpPr/>
           <p:nvPr/>
         </p:nvSpPr>
@@ -11557,7 +11431,7 @@
       </p:sp>
       <p:sp>
         <p:nvSpPr>
-          <p:cNvPr id="38" name="Text 35"/>
+          <p:cNvPr id="37" name="Text 33"/>
           <p:cNvSpPr txBox="1"/>
           <p:nvPr/>
         </p:nvSpPr>
@@ -11599,7 +11473,7 @@
       </p:sp>
       <p:sp>
         <p:nvSpPr>
-          <p:cNvPr id="39" name="Text 36"/>
+          <p:cNvPr id="38" name="Text 34"/>
           <p:cNvSpPr txBox="1"/>
           <p:nvPr/>
         </p:nvSpPr>
@@ -11641,7 +11515,7 @@
       </p:sp>
       <p:sp>
         <p:nvSpPr>
-          <p:cNvPr id="40" name="Text 37"/>
+          <p:cNvPr id="39" name="Text 35"/>
           <p:cNvSpPr txBox="1"/>
           <p:nvPr/>
         </p:nvSpPr>
@@ -11700,7 +11574,7 @@
       </p:sp>
       <p:sp>
         <p:nvSpPr>
-          <p:cNvPr id="41" name="Text 38"/>
+          <p:cNvPr id="40" name="Text 36"/>
           <p:cNvSpPr txBox="1"/>
           <p:nvPr/>
         </p:nvSpPr>
@@ -11759,7 +11633,7 @@
       </p:sp>
       <p:sp>
         <p:nvSpPr>
-          <p:cNvPr id="42" name="Text 39"/>
+          <p:cNvPr id="41" name="Text 37"/>
           <p:cNvSpPr txBox="1"/>
           <p:nvPr/>
         </p:nvSpPr>
@@ -11818,7 +11692,7 @@
       </p:sp>
       <p:sp>
         <p:nvSpPr>
-          <p:cNvPr id="43" name="Shape 40"/>
+          <p:cNvPr id="42" name="Shape 38"/>
           <p:cNvSpPr/>
           <p:nvPr/>
         </p:nvSpPr>
@@ -11841,7 +11715,7 @@
       </p:sp>
       <p:sp>
         <p:nvSpPr>
-          <p:cNvPr id="44" name="Text 41"/>
+          <p:cNvPr id="43" name="Text 39"/>
           <p:cNvSpPr txBox="1"/>
           <p:nvPr/>
         </p:nvSpPr>
@@ -11883,7 +11757,7 @@
       </p:sp>
       <p:sp>
         <p:nvSpPr>
-          <p:cNvPr id="45" name="Shape 42"/>
+          <p:cNvPr id="44" name="Shape 40"/>
           <p:cNvSpPr/>
           <p:nvPr/>
         </p:nvSpPr>
@@ -11908,7 +11782,7 @@
       </p:sp>
       <p:sp>
         <p:nvSpPr>
-          <p:cNvPr id="46" name="Text 43"/>
+          <p:cNvPr id="45" name="Text 41"/>
           <p:cNvSpPr txBox="1"/>
           <p:nvPr/>
         </p:nvSpPr>
@@ -11950,7 +11824,7 @@
       </p:sp>
       <p:sp>
         <p:nvSpPr>
-          <p:cNvPr id="47" name="Shape 44"/>
+          <p:cNvPr id="46" name="Shape 42"/>
           <p:cNvSpPr/>
           <p:nvPr/>
         </p:nvSpPr>
@@ -11975,7 +11849,7 @@
       </p:sp>
       <p:sp>
         <p:nvSpPr>
-          <p:cNvPr id="48" name="Text 45"/>
+          <p:cNvPr id="47" name="Text 43"/>
           <p:cNvSpPr txBox="1"/>
           <p:nvPr/>
         </p:nvSpPr>
@@ -12034,7 +11908,7 @@
       </p:sp>
       <p:sp>
         <p:nvSpPr>
-          <p:cNvPr id="49" name="Shape 46"/>
+          <p:cNvPr id="48" name="Shape 44"/>
           <p:cNvSpPr/>
           <p:nvPr/>
         </p:nvSpPr>
@@ -12059,7 +11933,7 @@
       </p:sp>
       <p:sp>
         <p:nvSpPr>
-          <p:cNvPr id="50" name="Text 47"/>
+          <p:cNvPr id="49" name="Text 45"/>
           <p:cNvSpPr txBox="1"/>
           <p:nvPr/>
         </p:nvSpPr>
@@ -12118,7 +11992,7 @@
       </p:sp>
       <p:sp>
         <p:nvSpPr>
-          <p:cNvPr id="51" name="Shape 48"/>
+          <p:cNvPr id="50" name="Shape 46"/>
           <p:cNvSpPr/>
           <p:nvPr/>
         </p:nvSpPr>
@@ -12143,7 +12017,7 @@
       </p:sp>
       <p:sp>
         <p:nvSpPr>
-          <p:cNvPr id="52" name="Text 49"/>
+          <p:cNvPr id="51" name="Text 47"/>
           <p:cNvSpPr txBox="1"/>
           <p:nvPr/>
         </p:nvSpPr>
@@ -12202,7 +12076,7 @@
       </p:sp>
       <p:sp>
         <p:nvSpPr>
-          <p:cNvPr id="53" name="Shape 50"/>
+          <p:cNvPr id="52" name="Shape 48"/>
           <p:cNvSpPr/>
           <p:nvPr/>
         </p:nvSpPr>
@@ -12227,7 +12101,7 @@
       </p:sp>
       <p:sp>
         <p:nvSpPr>
-          <p:cNvPr id="54" name="Text 51"/>
+          <p:cNvPr id="53" name="Text 49"/>
           <p:cNvSpPr txBox="1"/>
           <p:nvPr/>
         </p:nvSpPr>
@@ -12286,7 +12160,7 @@
       </p:sp>
       <p:sp>
         <p:nvSpPr>
-          <p:cNvPr id="55" name="Shape 52"/>
+          <p:cNvPr id="54" name="Shape 50"/>
           <p:cNvSpPr/>
           <p:nvPr/>
         </p:nvSpPr>
@@ -12311,7 +12185,7 @@
       </p:sp>
       <p:sp>
         <p:nvSpPr>
-          <p:cNvPr id="56" name="Text 53"/>
+          <p:cNvPr id="55" name="Text 51"/>
           <p:cNvSpPr txBox="1"/>
           <p:nvPr/>
         </p:nvSpPr>
@@ -12370,7 +12244,7 @@
       </p:sp>
       <p:sp>
         <p:nvSpPr>
-          <p:cNvPr id="57" name="Shape 54"/>
+          <p:cNvPr id="56" name="Shape 52"/>
           <p:cNvSpPr/>
           <p:nvPr/>
         </p:nvSpPr>
@@ -12395,7 +12269,7 @@
       </p:sp>
       <p:sp>
         <p:nvSpPr>
-          <p:cNvPr id="58" name="Text 55"/>
+          <p:cNvPr id="57" name="Text 53"/>
           <p:cNvSpPr txBox="1"/>
           <p:nvPr/>
         </p:nvSpPr>
@@ -12437,7 +12311,7 @@
       </p:sp>
       <p:sp>
         <p:nvSpPr>
-          <p:cNvPr id="59" name="Shape 56"/>
+          <p:cNvPr id="58" name="Shape 54"/>
           <p:cNvSpPr/>
           <p:nvPr/>
         </p:nvSpPr>
@@ -12462,7 +12336,7 @@
       </p:sp>
       <p:sp>
         <p:nvSpPr>
-          <p:cNvPr id="60" name="Text 57"/>
+          <p:cNvPr id="59" name="Text 55"/>
           <p:cNvSpPr txBox="1"/>
           <p:nvPr/>
         </p:nvSpPr>
@@ -12521,7 +12395,7 @@
       </p:sp>
       <p:sp>
         <p:nvSpPr>
-          <p:cNvPr id="61" name="Shape 58"/>
+          <p:cNvPr id="60" name="Shape 56"/>
           <p:cNvSpPr/>
           <p:nvPr/>
         </p:nvSpPr>
@@ -12546,7 +12420,7 @@
       </p:sp>
       <p:sp>
         <p:nvSpPr>
-          <p:cNvPr id="62" name="Text 59"/>
+          <p:cNvPr id="61" name="Text 57"/>
           <p:cNvSpPr txBox="1"/>
           <p:nvPr/>
         </p:nvSpPr>
@@ -12605,7 +12479,7 @@
       </p:sp>
       <p:sp>
         <p:nvSpPr>
-          <p:cNvPr id="63" name="Shape 60"/>
+          <p:cNvPr id="62" name="Shape 58"/>
           <p:cNvSpPr/>
           <p:nvPr/>
         </p:nvSpPr>
@@ -12630,7 +12504,7 @@
       </p:sp>
       <p:sp>
         <p:nvSpPr>
-          <p:cNvPr id="64" name="Text 61"/>
+          <p:cNvPr id="63" name="Text 59"/>
           <p:cNvSpPr txBox="1"/>
           <p:nvPr/>
         </p:nvSpPr>
@@ -12689,7 +12563,7 @@
       </p:sp>
       <p:sp>
         <p:nvSpPr>
-          <p:cNvPr id="65" name="Shape 62"/>
+          <p:cNvPr id="64" name="Shape 60"/>
           <p:cNvSpPr/>
           <p:nvPr/>
         </p:nvSpPr>
@@ -12714,7 +12588,7 @@
       </p:sp>
       <p:sp>
         <p:nvSpPr>
-          <p:cNvPr id="66" name="Text 63"/>
+          <p:cNvPr id="65" name="Text 61"/>
           <p:cNvSpPr txBox="1"/>
           <p:nvPr/>
         </p:nvSpPr>
@@ -12773,7 +12647,7 @@
       </p:sp>
       <p:sp>
         <p:nvSpPr>
-          <p:cNvPr id="67" name="Shape 64"/>
+          <p:cNvPr id="66" name="Shape 62"/>
           <p:cNvSpPr/>
           <p:nvPr/>
         </p:nvSpPr>
@@ -12798,7 +12672,7 @@
       </p:sp>
       <p:sp>
         <p:nvSpPr>
-          <p:cNvPr id="68" name="Text 65"/>
+          <p:cNvPr id="67" name="Text 63"/>
           <p:cNvSpPr txBox="1"/>
           <p:nvPr/>
         </p:nvSpPr>
@@ -12840,7 +12714,7 @@
       </p:sp>
       <p:sp>
         <p:nvSpPr>
-          <p:cNvPr id="69" name="Text 66"/>
+          <p:cNvPr id="68" name="Text 64"/>
           <p:cNvSpPr txBox="1"/>
           <p:nvPr/>
         </p:nvSpPr>
@@ -12899,7 +12773,7 @@
       </p:sp>
       <p:sp>
         <p:nvSpPr>
-          <p:cNvPr id="70" name="Text 67"/>
+          <p:cNvPr id="69" name="Text 65"/>
           <p:cNvSpPr txBox="1"/>
           <p:nvPr/>
         </p:nvSpPr>
@@ -12958,7 +12832,7 @@
       </p:sp>
       <p:sp>
         <p:nvSpPr>
-          <p:cNvPr id="71" name="Text 68"/>
+          <p:cNvPr id="70" name="Text 66"/>
           <p:cNvSpPr txBox="1"/>
           <p:nvPr/>
         </p:nvSpPr>
@@ -13017,7 +12891,7 @@
       </p:sp>
       <p:sp>
         <p:nvSpPr>
-          <p:cNvPr id="72" name="Shape 69"/>
+          <p:cNvPr id="71" name="Shape 67"/>
           <p:cNvSpPr/>
           <p:nvPr/>
         </p:nvSpPr>
@@ -13040,7 +12914,7 @@
       </p:sp>
       <p:sp>
         <p:nvSpPr>
-          <p:cNvPr id="73" name="Text 70"/>
+          <p:cNvPr id="72" name="Text 68"/>
           <p:cNvSpPr txBox="1"/>
           <p:nvPr/>
         </p:nvSpPr>
@@ -13175,81 +13049,39 @@
           </a:p>
         </p:txBody>
       </p:sp>
-      <p:sp>
-        <p:nvSpPr>
-          <p:cNvPr id="4" name="Shape 1"/>
+      <p:pic>
+        <p:nvPicPr>
+          <p:cNvPr id="4" name="Image 1" descr="../site/brand/jewell-wordmark.png">    </p:cNvPr>
+          <p:cNvPicPr>
+            <a:picLocks noChangeAspect="1"/>
+          </p:cNvPicPr>
+          <p:nvPr/>
+        </p:nvPicPr>
+        <p:blipFill>
+          <a:blip r:embed="rId2"/>
+          <a:stretch>
+            <a:fillRect/>
+          </a:stretch>
+        </p:blipFill>
+        <p:spPr>
+          <a:xfrm>
+            <a:off x="13915605" y="394290"/>
+            <a:ext cx="880302" cy="194400"/>
+          </a:xfrm>
+          <a:prstGeom prst="rect">
+            <a:avLst/>
+          </a:prstGeom>
+        </p:spPr>
+      </p:pic>
+      <p:sp>
+        <p:nvSpPr>
+          <p:cNvPr id="5" name="Shape 1"/>
           <p:cNvSpPr/>
           <p:nvPr/>
         </p:nvSpPr>
         <p:spPr>
           <a:xfrm>
-            <a:off x="13650938" y="365760"/>
-            <a:ext cx="1144969" cy="251460"/>
-          </a:xfrm>
-          <a:prstGeom prst="roundRect">
-            <a:avLst>
-              <a:gd name="adj" fmla="val 50000"/>
-            </a:avLst>
-          </a:prstGeom>
-          <a:solidFill>
-            <a:srgbClr val="0E171F"/>
-          </a:solidFill>
-          <a:ln w="9525">
-            <a:solidFill>
-              <a:srgbClr val="0E171F"/>
-            </a:solidFill>
-            <a:prstDash val="solid"/>
-          </a:ln>
-        </p:spPr>
-      </p:sp>
-      <p:sp>
-        <p:nvSpPr>
-          <p:cNvPr id="5" name="Text 2"/>
-          <p:cNvSpPr txBox="1"/>
-          <p:nvPr/>
-        </p:nvSpPr>
-        <p:spPr>
-          <a:xfrm>
-            <a:off x="13650938" y="365760"/>
-            <a:ext cx="1144969" cy="251460"/>
-          </a:xfrm>
-          <a:prstGeom prst="rect">
-            <a:avLst/>
-          </a:prstGeom>
-          <a:noFill/>
-          <a:ln/>
-        </p:spPr>
-        <p:txBody>
-          <a:bodyPr wrap="square" lIns="0" tIns="0" rIns="0" bIns="0" rtlCol="0" anchor="ctr"/>
-          <a:lstStyle/>
-          <a:p>
-            <a:pPr algn="ctr" indent="0" marL="0">
-              <a:buNone/>
-            </a:pPr>
-            <a:r>
-              <a:rPr lang="en-US" sz="650" b="1" spc="78" kern="0" dirty="0">
-                <a:solidFill>
-                  <a:srgbClr val="FFFFFF"/>
-                </a:solidFill>
-                <a:latin typeface="Poppins" pitchFamily="34" charset="0"/>
-                <a:ea typeface="Poppins" pitchFamily="34" charset="-122"/>
-                <a:cs typeface="Poppins" pitchFamily="34" charset="-120"/>
-              </a:rPr>
-              <a:t>JEWELL PROJECTS</a:t>
-            </a:r>
-            <a:endParaRPr lang="en-US" sz="650" dirty="0"/>
-          </a:p>
-        </p:txBody>
-      </p:sp>
-      <p:sp>
-        <p:nvSpPr>
-          <p:cNvPr id="6" name="Shape 3"/>
-          <p:cNvSpPr/>
-          <p:nvPr/>
-        </p:nvSpPr>
-        <p:spPr>
-          <a:xfrm>
-            <a:off x="12410462" y="365760"/>
+            <a:off x="12693129" y="365760"/>
             <a:ext cx="1150475" cy="251460"/>
           </a:xfrm>
           <a:prstGeom prst="roundRect">
@@ -13270,13 +13102,13 @@
       </p:sp>
       <p:sp>
         <p:nvSpPr>
-          <p:cNvPr id="7" name="Text 4"/>
+          <p:cNvPr id="6" name="Text 2"/>
           <p:cNvSpPr txBox="1"/>
           <p:nvPr/>
         </p:nvSpPr>
         <p:spPr>
           <a:xfrm>
-            <a:off x="12410462" y="365760"/>
+            <a:off x="12693129" y="365760"/>
             <a:ext cx="1150475" cy="251460"/>
           </a:xfrm>
           <a:prstGeom prst="rect">
@@ -13309,13 +13141,13 @@
       </p:sp>
       <p:sp>
         <p:nvSpPr>
-          <p:cNvPr id="8" name="Shape 5"/>
+          <p:cNvPr id="7" name="Shape 3"/>
           <p:cNvSpPr/>
           <p:nvPr/>
         </p:nvSpPr>
         <p:spPr>
           <a:xfrm>
-            <a:off x="11102419" y="365760"/>
+            <a:off x="11385086" y="365760"/>
             <a:ext cx="1218043" cy="251460"/>
           </a:xfrm>
           <a:prstGeom prst="roundRect">
@@ -13336,13 +13168,13 @@
       </p:sp>
       <p:sp>
         <p:nvSpPr>
-          <p:cNvPr id="9" name="Text 6"/>
+          <p:cNvPr id="8" name="Text 4"/>
           <p:cNvSpPr txBox="1"/>
           <p:nvPr/>
         </p:nvSpPr>
         <p:spPr>
           <a:xfrm>
-            <a:off x="11102419" y="365760"/>
+            <a:off x="11385086" y="365760"/>
             <a:ext cx="1218043" cy="251460"/>
           </a:xfrm>
           <a:prstGeom prst="rect">
@@ -13375,13 +13207,13 @@
       </p:sp>
       <p:sp>
         <p:nvSpPr>
-          <p:cNvPr id="10" name="Shape 7"/>
+          <p:cNvPr id="9" name="Shape 5"/>
           <p:cNvSpPr/>
           <p:nvPr/>
         </p:nvSpPr>
         <p:spPr>
           <a:xfrm>
-            <a:off x="10042472" y="365760"/>
+            <a:off x="10325139" y="365760"/>
             <a:ext cx="969947" cy="251460"/>
           </a:xfrm>
           <a:prstGeom prst="roundRect">
@@ -13394,7 +13226,7 @@
           </a:solidFill>
           <a:ln w="9525">
             <a:solidFill>
-              <a:srgbClr val="E3E7EC"/>
+              <a:srgbClr val="0066FF"/>
             </a:solidFill>
             <a:prstDash val="solid"/>
           </a:ln>
@@ -13402,13 +13234,13 @@
       </p:sp>
       <p:sp>
         <p:nvSpPr>
-          <p:cNvPr id="11" name="Text 8"/>
+          <p:cNvPr id="10" name="Text 6"/>
           <p:cNvSpPr txBox="1"/>
           <p:nvPr/>
         </p:nvSpPr>
         <p:spPr>
           <a:xfrm>
-            <a:off x="10042472" y="365760"/>
+            <a:off x="10325139" y="365760"/>
             <a:ext cx="969947" cy="251460"/>
           </a:xfrm>
           <a:prstGeom prst="rect">
@@ -13427,7 +13259,7 @@
             <a:r>
               <a:rPr lang="en-US" sz="650" b="1" spc="78" kern="0" dirty="0">
                 <a:solidFill>
-                  <a:srgbClr val="4A5565"/>
+                  <a:srgbClr val="0066FF"/>
                 </a:solidFill>
                 <a:latin typeface="Poppins" pitchFamily="34" charset="0"/>
                 <a:ea typeface="Poppins" pitchFamily="34" charset="-122"/>
@@ -13441,7 +13273,7 @@
       </p:sp>
       <p:sp>
         <p:nvSpPr>
-          <p:cNvPr id="12" name="Shape 9"/>
+          <p:cNvPr id="11" name="Shape 7"/>
           <p:cNvSpPr/>
           <p:nvPr/>
         </p:nvSpPr>
@@ -13464,7 +13296,7 @@
       </p:sp>
       <p:sp>
         <p:nvSpPr>
-          <p:cNvPr id="13" name="Shape 10"/>
+          <p:cNvPr id="12" name="Shape 8"/>
           <p:cNvSpPr/>
           <p:nvPr/>
         </p:nvSpPr>
@@ -13489,7 +13321,7 @@
       </p:sp>
       <p:sp>
         <p:nvSpPr>
-          <p:cNvPr id="14" name="Shape 11"/>
+          <p:cNvPr id="13" name="Shape 9"/>
           <p:cNvSpPr/>
           <p:nvPr/>
         </p:nvSpPr>
@@ -13514,7 +13346,7 @@
       </p:sp>
       <p:sp>
         <p:nvSpPr>
-          <p:cNvPr id="15" name="Text 12"/>
+          <p:cNvPr id="14" name="Text 10"/>
           <p:cNvSpPr txBox="1"/>
           <p:nvPr/>
         </p:nvSpPr>
@@ -13556,7 +13388,7 @@
       </p:sp>
       <p:sp>
         <p:nvSpPr>
-          <p:cNvPr id="16" name="Text 13"/>
+          <p:cNvPr id="15" name="Text 11"/>
           <p:cNvSpPr txBox="1"/>
           <p:nvPr/>
         </p:nvSpPr>
@@ -13598,7 +13430,7 @@
       </p:sp>
       <p:sp>
         <p:nvSpPr>
-          <p:cNvPr id="17" name="Shape 14"/>
+          <p:cNvPr id="16" name="Shape 12"/>
           <p:cNvSpPr/>
           <p:nvPr/>
         </p:nvSpPr>
@@ -13623,7 +13455,7 @@
       </p:sp>
       <p:sp>
         <p:nvSpPr>
-          <p:cNvPr id="18" name="Shape 15"/>
+          <p:cNvPr id="17" name="Shape 13"/>
           <p:cNvSpPr/>
           <p:nvPr/>
         </p:nvSpPr>
@@ -13648,7 +13480,7 @@
       </p:sp>
       <p:sp>
         <p:nvSpPr>
-          <p:cNvPr id="19" name="Text 16"/>
+          <p:cNvPr id="18" name="Text 14"/>
           <p:cNvSpPr txBox="1"/>
           <p:nvPr/>
         </p:nvSpPr>
@@ -13690,7 +13522,7 @@
       </p:sp>
       <p:sp>
         <p:nvSpPr>
-          <p:cNvPr id="20" name="Text 17"/>
+          <p:cNvPr id="19" name="Text 15"/>
           <p:cNvSpPr txBox="1"/>
           <p:nvPr/>
         </p:nvSpPr>
@@ -13732,7 +13564,7 @@
       </p:sp>
       <p:sp>
         <p:nvSpPr>
-          <p:cNvPr id="21" name="Text 18"/>
+          <p:cNvPr id="20" name="Text 16"/>
           <p:cNvSpPr txBox="1"/>
           <p:nvPr/>
         </p:nvSpPr>
@@ -13774,7 +13606,7 @@
       </p:sp>
       <p:sp>
         <p:nvSpPr>
-          <p:cNvPr id="22" name="Shape 19"/>
+          <p:cNvPr id="21" name="Shape 17"/>
           <p:cNvSpPr/>
           <p:nvPr/>
         </p:nvSpPr>
@@ -13799,7 +13631,7 @@
       </p:sp>
       <p:sp>
         <p:nvSpPr>
-          <p:cNvPr id="23" name="Shape 20"/>
+          <p:cNvPr id="22" name="Shape 18"/>
           <p:cNvSpPr/>
           <p:nvPr/>
         </p:nvSpPr>
@@ -13824,7 +13656,7 @@
       </p:sp>
       <p:sp>
         <p:nvSpPr>
-          <p:cNvPr id="24" name="Text 21"/>
+          <p:cNvPr id="23" name="Text 19"/>
           <p:cNvSpPr txBox="1"/>
           <p:nvPr/>
         </p:nvSpPr>
@@ -13866,7 +13698,7 @@
       </p:sp>
       <p:sp>
         <p:nvSpPr>
-          <p:cNvPr id="25" name="Text 22"/>
+          <p:cNvPr id="24" name="Text 20"/>
           <p:cNvSpPr txBox="1"/>
           <p:nvPr/>
         </p:nvSpPr>
@@ -13908,7 +13740,7 @@
       </p:sp>
       <p:sp>
         <p:nvSpPr>
-          <p:cNvPr id="26" name="Text 23"/>
+          <p:cNvPr id="25" name="Text 21"/>
           <p:cNvSpPr txBox="1"/>
           <p:nvPr/>
         </p:nvSpPr>
@@ -13950,7 +13782,7 @@
       </p:sp>
       <p:sp>
         <p:nvSpPr>
-          <p:cNvPr id="27" name="Shape 24"/>
+          <p:cNvPr id="26" name="Shape 22"/>
           <p:cNvSpPr/>
           <p:nvPr/>
         </p:nvSpPr>
@@ -13975,7 +13807,7 @@
       </p:sp>
       <p:sp>
         <p:nvSpPr>
-          <p:cNvPr id="28" name="Shape 25"/>
+          <p:cNvPr id="27" name="Shape 23"/>
           <p:cNvSpPr/>
           <p:nvPr/>
         </p:nvSpPr>
@@ -14000,7 +13832,7 @@
       </p:sp>
       <p:sp>
         <p:nvSpPr>
-          <p:cNvPr id="29" name="Text 26"/>
+          <p:cNvPr id="28" name="Text 24"/>
           <p:cNvSpPr txBox="1"/>
           <p:nvPr/>
         </p:nvSpPr>
@@ -14042,7 +13874,7 @@
       </p:sp>
       <p:sp>
         <p:nvSpPr>
-          <p:cNvPr id="30" name="Text 27"/>
+          <p:cNvPr id="29" name="Text 25"/>
           <p:cNvSpPr txBox="1"/>
           <p:nvPr/>
         </p:nvSpPr>
@@ -14084,7 +13916,7 @@
       </p:sp>
       <p:sp>
         <p:nvSpPr>
-          <p:cNvPr id="31" name="Text 28"/>
+          <p:cNvPr id="30" name="Text 26"/>
           <p:cNvSpPr txBox="1"/>
           <p:nvPr/>
         </p:nvSpPr>
@@ -14126,7 +13958,7 @@
       </p:sp>
       <p:sp>
         <p:nvSpPr>
-          <p:cNvPr id="32" name="Shape 29"/>
+          <p:cNvPr id="31" name="Shape 27"/>
           <p:cNvSpPr/>
           <p:nvPr/>
         </p:nvSpPr>
@@ -14151,7 +13983,7 @@
       </p:sp>
       <p:sp>
         <p:nvSpPr>
-          <p:cNvPr id="33" name="Shape 30"/>
+          <p:cNvPr id="32" name="Shape 28"/>
           <p:cNvSpPr/>
           <p:nvPr/>
         </p:nvSpPr>
@@ -14176,7 +14008,7 @@
       </p:sp>
       <p:sp>
         <p:nvSpPr>
-          <p:cNvPr id="34" name="Text 31"/>
+          <p:cNvPr id="33" name="Text 29"/>
           <p:cNvSpPr txBox="1"/>
           <p:nvPr/>
         </p:nvSpPr>
@@ -14218,7 +14050,7 @@
       </p:sp>
       <p:sp>
         <p:nvSpPr>
-          <p:cNvPr id="35" name="Text 32"/>
+          <p:cNvPr id="34" name="Text 30"/>
           <p:cNvSpPr txBox="1"/>
           <p:nvPr/>
         </p:nvSpPr>
@@ -14260,7 +14092,7 @@
       </p:sp>
       <p:sp>
         <p:nvSpPr>
-          <p:cNvPr id="36" name="Text 33"/>
+          <p:cNvPr id="35" name="Text 31"/>
           <p:cNvSpPr txBox="1"/>
           <p:nvPr/>
         </p:nvSpPr>
@@ -14302,7 +14134,7 @@
       </p:sp>
       <p:sp>
         <p:nvSpPr>
-          <p:cNvPr id="37" name="Shape 34"/>
+          <p:cNvPr id="36" name="Shape 32"/>
           <p:cNvSpPr/>
           <p:nvPr/>
         </p:nvSpPr>
@@ -14327,7 +14159,7 @@
       </p:sp>
       <p:sp>
         <p:nvSpPr>
-          <p:cNvPr id="38" name="Shape 35"/>
+          <p:cNvPr id="37" name="Shape 33"/>
           <p:cNvSpPr/>
           <p:nvPr/>
         </p:nvSpPr>
@@ -14352,7 +14184,7 @@
       </p:sp>
       <p:sp>
         <p:nvSpPr>
-          <p:cNvPr id="39" name="Text 36"/>
+          <p:cNvPr id="38" name="Text 34"/>
           <p:cNvSpPr txBox="1"/>
           <p:nvPr/>
         </p:nvSpPr>
@@ -14394,7 +14226,7 @@
       </p:sp>
       <p:sp>
         <p:nvSpPr>
-          <p:cNvPr id="40" name="Text 37"/>
+          <p:cNvPr id="39" name="Text 35"/>
           <p:cNvSpPr txBox="1"/>
           <p:nvPr/>
         </p:nvSpPr>
@@ -14436,7 +14268,7 @@
       </p:sp>
       <p:sp>
         <p:nvSpPr>
-          <p:cNvPr id="41" name="Text 38"/>
+          <p:cNvPr id="40" name="Text 36"/>
           <p:cNvSpPr txBox="1"/>
           <p:nvPr/>
         </p:nvSpPr>
@@ -14478,7 +14310,7 @@
       </p:sp>
       <p:sp>
         <p:nvSpPr>
-          <p:cNvPr id="42" name="Shape 39"/>
+          <p:cNvPr id="41" name="Shape 37"/>
           <p:cNvSpPr/>
           <p:nvPr/>
         </p:nvSpPr>
@@ -14501,7 +14333,7 @@
       </p:sp>
       <p:sp>
         <p:nvSpPr>
-          <p:cNvPr id="43" name="Text 40"/>
+          <p:cNvPr id="42" name="Text 38"/>
           <p:cNvSpPr txBox="1"/>
           <p:nvPr/>
         </p:nvSpPr>
@@ -14543,7 +14375,7 @@
       </p:sp>
       <p:sp>
         <p:nvSpPr>
-          <p:cNvPr id="44" name="Shape 41"/>
+          <p:cNvPr id="43" name="Shape 39"/>
           <p:cNvSpPr/>
           <p:nvPr/>
         </p:nvSpPr>
@@ -14568,7 +14400,7 @@
       </p:sp>
       <p:sp>
         <p:nvSpPr>
-          <p:cNvPr id="45" name="Text 42"/>
+          <p:cNvPr id="44" name="Text 40"/>
           <p:cNvSpPr txBox="1"/>
           <p:nvPr/>
         </p:nvSpPr>
@@ -15420,7 +15252,7 @@
       </p:graphicFrame>
       <p:sp>
         <p:nvSpPr>
-          <p:cNvPr id="47" name="Shape 43"/>
+          <p:cNvPr id="46" name="Shape 41"/>
           <p:cNvSpPr/>
           <p:nvPr/>
         </p:nvSpPr>
@@ -15445,7 +15277,7 @@
       </p:sp>
       <p:sp>
         <p:nvSpPr>
-          <p:cNvPr id="48" name="Text 44"/>
+          <p:cNvPr id="47" name="Text 42"/>
           <p:cNvSpPr txBox="1"/>
           <p:nvPr/>
         </p:nvSpPr>
@@ -15487,7 +15319,7 @@
       </p:sp>
       <p:sp>
         <p:nvSpPr>
-          <p:cNvPr id="49" name="Text 45"/>
+          <p:cNvPr id="48" name="Text 43"/>
           <p:cNvSpPr txBox="1"/>
           <p:nvPr/>
         </p:nvSpPr>
@@ -15529,7 +15361,7 @@
       </p:sp>
       <p:sp>
         <p:nvSpPr>
-          <p:cNvPr id="50" name="Text 46"/>
+          <p:cNvPr id="49" name="Text 44"/>
           <p:cNvSpPr txBox="1"/>
           <p:nvPr/>
         </p:nvSpPr>
@@ -15571,7 +15403,7 @@
       </p:sp>
       <p:sp>
         <p:nvSpPr>
-          <p:cNvPr id="51" name="Text 47"/>
+          <p:cNvPr id="50" name="Text 45"/>
           <p:cNvSpPr txBox="1"/>
           <p:nvPr/>
         </p:nvSpPr>
@@ -15613,7 +15445,7 @@
       </p:sp>
       <p:sp>
         <p:nvSpPr>
-          <p:cNvPr id="52" name="Text 48"/>
+          <p:cNvPr id="51" name="Text 46"/>
           <p:cNvSpPr txBox="1"/>
           <p:nvPr/>
         </p:nvSpPr>
@@ -15655,7 +15487,7 @@
       </p:sp>
       <p:sp>
         <p:nvSpPr>
-          <p:cNvPr id="53" name="Text 49"/>
+          <p:cNvPr id="52" name="Text 47"/>
           <p:cNvSpPr txBox="1"/>
           <p:nvPr/>
         </p:nvSpPr>
@@ -15697,7 +15529,7 @@
       </p:sp>
       <p:sp>
         <p:nvSpPr>
-          <p:cNvPr id="54" name="Text 50"/>
+          <p:cNvPr id="53" name="Text 48"/>
           <p:cNvSpPr txBox="1"/>
           <p:nvPr/>
         </p:nvSpPr>
@@ -15773,7 +15605,7 @@
       </p:sp>
       <p:sp>
         <p:nvSpPr>
-          <p:cNvPr id="55" name="Shape 51"/>
+          <p:cNvPr id="54" name="Shape 49"/>
           <p:cNvSpPr/>
           <p:nvPr/>
         </p:nvSpPr>
@@ -15796,7 +15628,7 @@
       </p:sp>
       <p:sp>
         <p:nvSpPr>
-          <p:cNvPr id="56" name="Text 52"/>
+          <p:cNvPr id="55" name="Text 50"/>
           <p:cNvSpPr txBox="1"/>
           <p:nvPr/>
         </p:nvSpPr>
@@ -15838,7 +15670,7 @@
       </p:sp>
       <p:sp>
         <p:nvSpPr>
-          <p:cNvPr id="57" name="Shape 53"/>
+          <p:cNvPr id="56" name="Shape 51"/>
           <p:cNvSpPr/>
           <p:nvPr/>
         </p:nvSpPr>
@@ -15863,7 +15695,7 @@
       </p:sp>
       <p:sp>
         <p:nvSpPr>
-          <p:cNvPr id="58" name="Text 54"/>
+          <p:cNvPr id="57" name="Text 52"/>
           <p:cNvSpPr txBox="1"/>
           <p:nvPr/>
         </p:nvSpPr>
@@ -15905,7 +15737,7 @@
       </p:sp>
       <p:sp>
         <p:nvSpPr>
-          <p:cNvPr id="59" name="Text 55"/>
+          <p:cNvPr id="58" name="Text 53"/>
           <p:cNvSpPr txBox="1"/>
           <p:nvPr/>
         </p:nvSpPr>
@@ -15947,7 +15779,7 @@
       </p:sp>
       <p:sp>
         <p:nvSpPr>
-          <p:cNvPr id="60" name="Text 56"/>
+          <p:cNvPr id="59" name="Text 54"/>
           <p:cNvSpPr txBox="1"/>
           <p:nvPr/>
         </p:nvSpPr>
@@ -16006,7 +15838,7 @@
       </p:sp>
       <p:sp>
         <p:nvSpPr>
-          <p:cNvPr id="61" name="Text 57"/>
+          <p:cNvPr id="60" name="Text 55"/>
           <p:cNvSpPr txBox="1"/>
           <p:nvPr/>
         </p:nvSpPr>
@@ -16065,7 +15897,7 @@
       </p:sp>
       <p:sp>
         <p:nvSpPr>
-          <p:cNvPr id="62" name="Text 58"/>
+          <p:cNvPr id="61" name="Text 56"/>
           <p:cNvSpPr txBox="1"/>
           <p:nvPr/>
         </p:nvSpPr>
@@ -16124,7 +15956,7 @@
       </p:sp>
       <p:sp>
         <p:nvSpPr>
-          <p:cNvPr id="63" name="Shape 59"/>
+          <p:cNvPr id="62" name="Shape 57"/>
           <p:cNvSpPr/>
           <p:nvPr/>
         </p:nvSpPr>
@@ -16147,7 +15979,7 @@
       </p:sp>
       <p:sp>
         <p:nvSpPr>
-          <p:cNvPr id="64" name="Text 60"/>
+          <p:cNvPr id="63" name="Text 58"/>
           <p:cNvSpPr txBox="1"/>
           <p:nvPr/>
         </p:nvSpPr>
@@ -16189,7 +16021,7 @@
       </p:sp>
       <p:sp>
         <p:nvSpPr>
-          <p:cNvPr id="65" name="Shape 61"/>
+          <p:cNvPr id="64" name="Shape 59"/>
           <p:cNvSpPr/>
           <p:nvPr/>
         </p:nvSpPr>
@@ -16214,7 +16046,7 @@
       </p:sp>
       <p:sp>
         <p:nvSpPr>
-          <p:cNvPr id="66" name="Text 62"/>
+          <p:cNvPr id="65" name="Text 60"/>
           <p:cNvSpPr txBox="1"/>
           <p:nvPr/>
         </p:nvSpPr>
@@ -16256,7 +16088,7 @@
       </p:sp>
       <p:sp>
         <p:nvSpPr>
-          <p:cNvPr id="67" name="Text 63"/>
+          <p:cNvPr id="66" name="Text 61"/>
           <p:cNvSpPr txBox="1"/>
           <p:nvPr/>
         </p:nvSpPr>
@@ -16298,7 +16130,7 @@
       </p:sp>
       <p:sp>
         <p:nvSpPr>
-          <p:cNvPr id="68" name="Text 64"/>
+          <p:cNvPr id="67" name="Text 62"/>
           <p:cNvSpPr txBox="1"/>
           <p:nvPr/>
         </p:nvSpPr>
@@ -16357,7 +16189,7 @@
       </p:sp>
       <p:sp>
         <p:nvSpPr>
-          <p:cNvPr id="69" name="Text 65"/>
+          <p:cNvPr id="68" name="Text 63"/>
           <p:cNvSpPr txBox="1"/>
           <p:nvPr/>
         </p:nvSpPr>
@@ -16416,7 +16248,7 @@
       </p:sp>
       <p:sp>
         <p:nvSpPr>
-          <p:cNvPr id="70" name="Text 66"/>
+          <p:cNvPr id="69" name="Text 64"/>
           <p:cNvSpPr txBox="1"/>
           <p:nvPr/>
         </p:nvSpPr>
@@ -16475,7 +16307,7 @@
       </p:sp>
       <p:sp>
         <p:nvSpPr>
-          <p:cNvPr id="71" name="Shape 67"/>
+          <p:cNvPr id="70" name="Shape 65"/>
           <p:cNvSpPr/>
           <p:nvPr/>
         </p:nvSpPr>
@@ -16500,7 +16332,7 @@
       </p:sp>
       <p:sp>
         <p:nvSpPr>
-          <p:cNvPr id="72" name="Text 68"/>
+          <p:cNvPr id="71" name="Text 66"/>
           <p:cNvSpPr txBox="1"/>
           <p:nvPr/>
         </p:nvSpPr>
@@ -16542,7 +16374,7 @@
       </p:sp>
       <p:sp>
         <p:nvSpPr>
-          <p:cNvPr id="73" name="Shape 69"/>
+          <p:cNvPr id="72" name="Shape 67"/>
           <p:cNvSpPr/>
           <p:nvPr/>
         </p:nvSpPr>
@@ -16567,7 +16399,7 @@
       </p:sp>
       <p:sp>
         <p:nvSpPr>
-          <p:cNvPr id="74" name="Text 70"/>
+          <p:cNvPr id="73" name="Text 68"/>
           <p:cNvSpPr txBox="1"/>
           <p:nvPr/>
         </p:nvSpPr>
@@ -16609,7 +16441,7 @@
       </p:sp>
       <p:sp>
         <p:nvSpPr>
-          <p:cNvPr id="75" name="Text 71"/>
+          <p:cNvPr id="74" name="Text 69"/>
           <p:cNvSpPr txBox="1"/>
           <p:nvPr/>
         </p:nvSpPr>
@@ -16651,7 +16483,7 @@
       </p:sp>
       <p:sp>
         <p:nvSpPr>
-          <p:cNvPr id="76" name="Shape 72"/>
+          <p:cNvPr id="75" name="Shape 70"/>
           <p:cNvSpPr/>
           <p:nvPr/>
         </p:nvSpPr>
@@ -16676,7 +16508,7 @@
       </p:sp>
       <p:sp>
         <p:nvSpPr>
-          <p:cNvPr id="77" name="Text 73"/>
+          <p:cNvPr id="76" name="Text 71"/>
           <p:cNvSpPr txBox="1"/>
           <p:nvPr/>
         </p:nvSpPr>
@@ -16718,7 +16550,7 @@
       </p:sp>
       <p:sp>
         <p:nvSpPr>
-          <p:cNvPr id="78" name="Text 74"/>
+          <p:cNvPr id="77" name="Text 72"/>
           <p:cNvSpPr txBox="1"/>
           <p:nvPr/>
         </p:nvSpPr>
@@ -16760,7 +16592,7 @@
       </p:sp>
       <p:sp>
         <p:nvSpPr>
-          <p:cNvPr id="79" name="Shape 75"/>
+          <p:cNvPr id="78" name="Shape 73"/>
           <p:cNvSpPr/>
           <p:nvPr/>
         </p:nvSpPr>
@@ -16785,7 +16617,7 @@
       </p:sp>
       <p:sp>
         <p:nvSpPr>
-          <p:cNvPr id="80" name="Text 76"/>
+          <p:cNvPr id="79" name="Text 74"/>
           <p:cNvSpPr txBox="1"/>
           <p:nvPr/>
         </p:nvSpPr>
@@ -16827,7 +16659,7 @@
       </p:sp>
       <p:sp>
         <p:nvSpPr>
-          <p:cNvPr id="81" name="Text 77"/>
+          <p:cNvPr id="80" name="Text 75"/>
           <p:cNvSpPr txBox="1"/>
           <p:nvPr/>
         </p:nvSpPr>
@@ -16869,7 +16701,7 @@
       </p:sp>
       <p:sp>
         <p:nvSpPr>
-          <p:cNvPr id="82" name="Shape 78"/>
+          <p:cNvPr id="81" name="Shape 76"/>
           <p:cNvSpPr/>
           <p:nvPr/>
         </p:nvSpPr>
@@ -16894,7 +16726,7 @@
       </p:sp>
       <p:sp>
         <p:nvSpPr>
-          <p:cNvPr id="83" name="Text 79"/>
+          <p:cNvPr id="82" name="Text 77"/>
           <p:cNvSpPr txBox="1"/>
           <p:nvPr/>
         </p:nvSpPr>
@@ -16936,7 +16768,7 @@
       </p:sp>
       <p:sp>
         <p:nvSpPr>
-          <p:cNvPr id="84" name="Text 80"/>
+          <p:cNvPr id="83" name="Text 78"/>
           <p:cNvSpPr txBox="1"/>
           <p:nvPr/>
         </p:nvSpPr>
@@ -16978,7 +16810,7 @@
       </p:sp>
       <p:sp>
         <p:nvSpPr>
-          <p:cNvPr id="85" name="Text 81"/>
+          <p:cNvPr id="84" name="Text 79"/>
           <p:cNvSpPr txBox="1"/>
           <p:nvPr/>
         </p:nvSpPr>
@@ -17037,7 +16869,7 @@
       </p:sp>
       <p:sp>
         <p:nvSpPr>
-          <p:cNvPr id="86" name="Text 82"/>
+          <p:cNvPr id="85" name="Text 80"/>
           <p:cNvSpPr txBox="1"/>
           <p:nvPr/>
         </p:nvSpPr>
@@ -17189,81 +17021,39 @@
           </a:p>
         </p:txBody>
       </p:sp>
-      <p:sp>
-        <p:nvSpPr>
-          <p:cNvPr id="4" name="Shape 1"/>
+      <p:pic>
+        <p:nvPicPr>
+          <p:cNvPr id="4" name="Image 1" descr="../site/brand/jewell-wordmark.png">    </p:cNvPr>
+          <p:cNvPicPr>
+            <a:picLocks noChangeAspect="1"/>
+          </p:cNvPicPr>
+          <p:nvPr/>
+        </p:nvPicPr>
+        <p:blipFill>
+          <a:blip r:embed="rId2"/>
+          <a:stretch>
+            <a:fillRect/>
+          </a:stretch>
+        </p:blipFill>
+        <p:spPr>
+          <a:xfrm>
+            <a:off x="13915605" y="394290"/>
+            <a:ext cx="880302" cy="194400"/>
+          </a:xfrm>
+          <a:prstGeom prst="rect">
+            <a:avLst/>
+          </a:prstGeom>
+        </p:spPr>
+      </p:pic>
+      <p:sp>
+        <p:nvSpPr>
+          <p:cNvPr id="5" name="Shape 1"/>
           <p:cNvSpPr/>
           <p:nvPr/>
         </p:nvSpPr>
         <p:spPr>
           <a:xfrm>
-            <a:off x="13650938" y="365760"/>
-            <a:ext cx="1144969" cy="251460"/>
-          </a:xfrm>
-          <a:prstGeom prst="roundRect">
-            <a:avLst>
-              <a:gd name="adj" fmla="val 50000"/>
-            </a:avLst>
-          </a:prstGeom>
-          <a:solidFill>
-            <a:srgbClr val="0E171F"/>
-          </a:solidFill>
-          <a:ln w="9525">
-            <a:solidFill>
-              <a:srgbClr val="0E171F"/>
-            </a:solidFill>
-            <a:prstDash val="solid"/>
-          </a:ln>
-        </p:spPr>
-      </p:sp>
-      <p:sp>
-        <p:nvSpPr>
-          <p:cNvPr id="5" name="Text 2"/>
-          <p:cNvSpPr txBox="1"/>
-          <p:nvPr/>
-        </p:nvSpPr>
-        <p:spPr>
-          <a:xfrm>
-            <a:off x="13650938" y="365760"/>
-            <a:ext cx="1144969" cy="251460"/>
-          </a:xfrm>
-          <a:prstGeom prst="rect">
-            <a:avLst/>
-          </a:prstGeom>
-          <a:noFill/>
-          <a:ln/>
-        </p:spPr>
-        <p:txBody>
-          <a:bodyPr wrap="square" lIns="0" tIns="0" rIns="0" bIns="0" rtlCol="0" anchor="ctr"/>
-          <a:lstStyle/>
-          <a:p>
-            <a:pPr algn="ctr" indent="0" marL="0">
-              <a:buNone/>
-            </a:pPr>
-            <a:r>
-              <a:rPr lang="en-US" sz="650" b="1" spc="78" kern="0" dirty="0">
-                <a:solidFill>
-                  <a:srgbClr val="FFFFFF"/>
-                </a:solidFill>
-                <a:latin typeface="Poppins" pitchFamily="34" charset="0"/>
-                <a:ea typeface="Poppins" pitchFamily="34" charset="-122"/>
-                <a:cs typeface="Poppins" pitchFamily="34" charset="-120"/>
-              </a:rPr>
-              <a:t>JEWELL PROJECTS</a:t>
-            </a:r>
-            <a:endParaRPr lang="en-US" sz="650" dirty="0"/>
-          </a:p>
-        </p:txBody>
-      </p:sp>
-      <p:sp>
-        <p:nvSpPr>
-          <p:cNvPr id="6" name="Shape 3"/>
-          <p:cNvSpPr/>
-          <p:nvPr/>
-        </p:nvSpPr>
-        <p:spPr>
-          <a:xfrm>
-            <a:off x="12410462" y="365760"/>
+            <a:off x="12693129" y="365760"/>
             <a:ext cx="1150475" cy="251460"/>
           </a:xfrm>
           <a:prstGeom prst="roundRect">
@@ -17284,13 +17074,13 @@
       </p:sp>
       <p:sp>
         <p:nvSpPr>
-          <p:cNvPr id="7" name="Text 4"/>
+          <p:cNvPr id="6" name="Text 2"/>
           <p:cNvSpPr txBox="1"/>
           <p:nvPr/>
         </p:nvSpPr>
         <p:spPr>
           <a:xfrm>
-            <a:off x="12410462" y="365760"/>
+            <a:off x="12693129" y="365760"/>
             <a:ext cx="1150475" cy="251460"/>
           </a:xfrm>
           <a:prstGeom prst="rect">
@@ -17323,13 +17113,13 @@
       </p:sp>
       <p:sp>
         <p:nvSpPr>
-          <p:cNvPr id="8" name="Shape 5"/>
+          <p:cNvPr id="7" name="Shape 3"/>
           <p:cNvSpPr/>
           <p:nvPr/>
         </p:nvSpPr>
         <p:spPr>
           <a:xfrm>
-            <a:off x="11102419" y="365760"/>
+            <a:off x="11385086" y="365760"/>
             <a:ext cx="1218043" cy="251460"/>
           </a:xfrm>
           <a:prstGeom prst="roundRect">
@@ -17350,13 +17140,13 @@
       </p:sp>
       <p:sp>
         <p:nvSpPr>
-          <p:cNvPr id="9" name="Text 6"/>
+          <p:cNvPr id="8" name="Text 4"/>
           <p:cNvSpPr txBox="1"/>
           <p:nvPr/>
         </p:nvSpPr>
         <p:spPr>
           <a:xfrm>
-            <a:off x="11102419" y="365760"/>
+            <a:off x="11385086" y="365760"/>
             <a:ext cx="1218043" cy="251460"/>
           </a:xfrm>
           <a:prstGeom prst="rect">
@@ -17389,13 +17179,13 @@
       </p:sp>
       <p:sp>
         <p:nvSpPr>
-          <p:cNvPr id="10" name="Shape 7"/>
+          <p:cNvPr id="9" name="Shape 5"/>
           <p:cNvSpPr/>
           <p:nvPr/>
         </p:nvSpPr>
         <p:spPr>
           <a:xfrm>
-            <a:off x="10036519" y="365760"/>
+            <a:off x="10319186" y="365760"/>
             <a:ext cx="975900" cy="251460"/>
           </a:xfrm>
           <a:prstGeom prst="roundRect">
@@ -17408,7 +17198,7 @@
           </a:solidFill>
           <a:ln w="9525">
             <a:solidFill>
-              <a:srgbClr val="E3E7EC"/>
+              <a:srgbClr val="0066FF"/>
             </a:solidFill>
             <a:prstDash val="solid"/>
           </a:ln>
@@ -17416,13 +17206,13 @@
       </p:sp>
       <p:sp>
         <p:nvSpPr>
-          <p:cNvPr id="11" name="Text 8"/>
+          <p:cNvPr id="10" name="Text 6"/>
           <p:cNvSpPr txBox="1"/>
           <p:nvPr/>
         </p:nvSpPr>
         <p:spPr>
           <a:xfrm>
-            <a:off x="10036519" y="365760"/>
+            <a:off x="10319186" y="365760"/>
             <a:ext cx="975900" cy="251460"/>
           </a:xfrm>
           <a:prstGeom prst="rect">
@@ -17441,7 +17231,7 @@
             <a:r>
               <a:rPr lang="en-US" sz="650" b="1" spc="78" kern="0" dirty="0">
                 <a:solidFill>
-                  <a:srgbClr val="4A5565"/>
+                  <a:srgbClr val="0066FF"/>
                 </a:solidFill>
                 <a:latin typeface="Poppins" pitchFamily="34" charset="0"/>
                 <a:ea typeface="Poppins" pitchFamily="34" charset="-122"/>
@@ -17455,7 +17245,7 @@
       </p:sp>
       <p:sp>
         <p:nvSpPr>
-          <p:cNvPr id="12" name="Shape 9"/>
+          <p:cNvPr id="11" name="Shape 7"/>
           <p:cNvSpPr/>
           <p:nvPr/>
         </p:nvSpPr>
@@ -17478,7 +17268,7 @@
       </p:sp>
       <p:sp>
         <p:nvSpPr>
-          <p:cNvPr id="13" name="Shape 10"/>
+          <p:cNvPr id="12" name="Shape 8"/>
           <p:cNvSpPr/>
           <p:nvPr/>
         </p:nvSpPr>
@@ -17503,7 +17293,7 @@
       </p:sp>
       <p:sp>
         <p:nvSpPr>
-          <p:cNvPr id="14" name="Shape 11"/>
+          <p:cNvPr id="13" name="Shape 9"/>
           <p:cNvSpPr/>
           <p:nvPr/>
         </p:nvSpPr>
@@ -17528,7 +17318,7 @@
       </p:sp>
       <p:sp>
         <p:nvSpPr>
-          <p:cNvPr id="15" name="Text 12"/>
+          <p:cNvPr id="14" name="Text 10"/>
           <p:cNvSpPr txBox="1"/>
           <p:nvPr/>
         </p:nvSpPr>
@@ -17587,7 +17377,7 @@
       </p:sp>
       <p:sp>
         <p:nvSpPr>
-          <p:cNvPr id="16" name="Shape 13"/>
+          <p:cNvPr id="15" name="Shape 11"/>
           <p:cNvSpPr/>
           <p:nvPr/>
         </p:nvSpPr>
@@ -17612,7 +17402,7 @@
       </p:sp>
       <p:sp>
         <p:nvSpPr>
-          <p:cNvPr id="17" name="Shape 14"/>
+          <p:cNvPr id="16" name="Shape 12"/>
           <p:cNvSpPr/>
           <p:nvPr/>
         </p:nvSpPr>
@@ -17637,7 +17427,7 @@
       </p:sp>
       <p:sp>
         <p:nvSpPr>
-          <p:cNvPr id="18" name="Text 15"/>
+          <p:cNvPr id="17" name="Text 13"/>
           <p:cNvSpPr txBox="1"/>
           <p:nvPr/>
         </p:nvSpPr>
@@ -17679,7 +17469,7 @@
       </p:sp>
       <p:sp>
         <p:nvSpPr>
-          <p:cNvPr id="19" name="Shape 16"/>
+          <p:cNvPr id="18" name="Shape 14"/>
           <p:cNvSpPr/>
           <p:nvPr/>
         </p:nvSpPr>
@@ -17704,7 +17494,7 @@
       </p:sp>
       <p:sp>
         <p:nvSpPr>
-          <p:cNvPr id="20" name="Text 17"/>
+          <p:cNvPr id="19" name="Text 15"/>
           <p:cNvSpPr txBox="1"/>
           <p:nvPr/>
         </p:nvSpPr>
@@ -17746,7 +17536,7 @@
       </p:sp>
       <p:sp>
         <p:nvSpPr>
-          <p:cNvPr id="21" name="Shape 18"/>
+          <p:cNvPr id="20" name="Shape 16"/>
           <p:cNvSpPr/>
           <p:nvPr/>
         </p:nvSpPr>
@@ -17771,7 +17561,7 @@
       </p:sp>
       <p:sp>
         <p:nvSpPr>
-          <p:cNvPr id="22" name="Text 19"/>
+          <p:cNvPr id="21" name="Text 17"/>
           <p:cNvSpPr txBox="1"/>
           <p:nvPr/>
         </p:nvSpPr>
@@ -17813,7 +17603,7 @@
       </p:sp>
       <p:sp>
         <p:nvSpPr>
-          <p:cNvPr id="23" name="Shape 20"/>
+          <p:cNvPr id="22" name="Shape 18"/>
           <p:cNvSpPr/>
           <p:nvPr/>
         </p:nvSpPr>
@@ -17838,7 +17628,7 @@
       </p:sp>
       <p:sp>
         <p:nvSpPr>
-          <p:cNvPr id="24" name="Text 21"/>
+          <p:cNvPr id="23" name="Text 19"/>
           <p:cNvSpPr txBox="1"/>
           <p:nvPr/>
         </p:nvSpPr>
@@ -17880,7 +17670,7 @@
       </p:sp>
       <p:sp>
         <p:nvSpPr>
-          <p:cNvPr id="25" name="Shape 22"/>
+          <p:cNvPr id="24" name="Shape 20"/>
           <p:cNvSpPr/>
           <p:nvPr/>
         </p:nvSpPr>
@@ -17905,7 +17695,7 @@
       </p:sp>
       <p:sp>
         <p:nvSpPr>
-          <p:cNvPr id="26" name="Text 23"/>
+          <p:cNvPr id="25" name="Text 21"/>
           <p:cNvSpPr txBox="1"/>
           <p:nvPr/>
         </p:nvSpPr>
@@ -17947,7 +17737,7 @@
       </p:sp>
       <p:sp>
         <p:nvSpPr>
-          <p:cNvPr id="27" name="Shape 24"/>
+          <p:cNvPr id="26" name="Shape 22"/>
           <p:cNvSpPr/>
           <p:nvPr/>
         </p:nvSpPr>
@@ -17972,7 +17762,7 @@
       </p:sp>
       <p:sp>
         <p:nvSpPr>
-          <p:cNvPr id="28" name="Shape 25"/>
+          <p:cNvPr id="27" name="Shape 23"/>
           <p:cNvSpPr/>
           <p:nvPr/>
         </p:nvSpPr>
@@ -17997,7 +17787,7 @@
       </p:sp>
       <p:sp>
         <p:nvSpPr>
-          <p:cNvPr id="29" name="Text 26"/>
+          <p:cNvPr id="28" name="Text 24"/>
           <p:cNvSpPr txBox="1"/>
           <p:nvPr/>
         </p:nvSpPr>
@@ -18039,7 +17829,7 @@
       </p:sp>
       <p:sp>
         <p:nvSpPr>
-          <p:cNvPr id="30" name="Shape 27"/>
+          <p:cNvPr id="29" name="Shape 25"/>
           <p:cNvSpPr/>
           <p:nvPr/>
         </p:nvSpPr>
@@ -18064,7 +17854,7 @@
       </p:sp>
       <p:sp>
         <p:nvSpPr>
-          <p:cNvPr id="31" name="Text 28"/>
+          <p:cNvPr id="30" name="Text 26"/>
           <p:cNvSpPr txBox="1"/>
           <p:nvPr/>
         </p:nvSpPr>
@@ -18106,7 +17896,7 @@
       </p:sp>
       <p:sp>
         <p:nvSpPr>
-          <p:cNvPr id="32" name="Shape 29"/>
+          <p:cNvPr id="31" name="Shape 27"/>
           <p:cNvSpPr/>
           <p:nvPr/>
         </p:nvSpPr>
@@ -18131,7 +17921,7 @@
       </p:sp>
       <p:sp>
         <p:nvSpPr>
-          <p:cNvPr id="33" name="Text 30"/>
+          <p:cNvPr id="32" name="Text 28"/>
           <p:cNvSpPr txBox="1"/>
           <p:nvPr/>
         </p:nvSpPr>
@@ -18173,7 +17963,7 @@
       </p:sp>
       <p:sp>
         <p:nvSpPr>
-          <p:cNvPr id="34" name="Shape 31"/>
+          <p:cNvPr id="33" name="Shape 29"/>
           <p:cNvSpPr/>
           <p:nvPr/>
         </p:nvSpPr>
@@ -18198,7 +17988,7 @@
       </p:sp>
       <p:sp>
         <p:nvSpPr>
-          <p:cNvPr id="35" name="Text 32"/>
+          <p:cNvPr id="34" name="Text 30"/>
           <p:cNvSpPr txBox="1"/>
           <p:nvPr/>
         </p:nvSpPr>
@@ -18240,7 +18030,7 @@
       </p:sp>
       <p:sp>
         <p:nvSpPr>
-          <p:cNvPr id="36" name="Shape 33"/>
+          <p:cNvPr id="35" name="Shape 31"/>
           <p:cNvSpPr/>
           <p:nvPr/>
         </p:nvSpPr>
@@ -18265,7 +18055,7 @@
       </p:sp>
       <p:sp>
         <p:nvSpPr>
-          <p:cNvPr id="37" name="Text 34"/>
+          <p:cNvPr id="36" name="Text 32"/>
           <p:cNvSpPr txBox="1"/>
           <p:nvPr/>
         </p:nvSpPr>
@@ -18307,7 +18097,7 @@
       </p:sp>
       <p:sp>
         <p:nvSpPr>
-          <p:cNvPr id="38" name="Shape 35"/>
+          <p:cNvPr id="37" name="Shape 33"/>
           <p:cNvSpPr/>
           <p:nvPr/>
         </p:nvSpPr>
@@ -18332,7 +18122,7 @@
       </p:sp>
       <p:sp>
         <p:nvSpPr>
-          <p:cNvPr id="39" name="Shape 36"/>
+          <p:cNvPr id="38" name="Shape 34"/>
           <p:cNvSpPr/>
           <p:nvPr/>
         </p:nvSpPr>
@@ -18357,7 +18147,7 @@
       </p:sp>
       <p:sp>
         <p:nvSpPr>
-          <p:cNvPr id="40" name="Text 37"/>
+          <p:cNvPr id="39" name="Text 35"/>
           <p:cNvSpPr txBox="1"/>
           <p:nvPr/>
         </p:nvSpPr>
@@ -18399,7 +18189,7 @@
       </p:sp>
       <p:sp>
         <p:nvSpPr>
-          <p:cNvPr id="41" name="Shape 38"/>
+          <p:cNvPr id="40" name="Shape 36"/>
           <p:cNvSpPr/>
           <p:nvPr/>
         </p:nvSpPr>
@@ -18424,7 +18214,7 @@
       </p:sp>
       <p:sp>
         <p:nvSpPr>
-          <p:cNvPr id="42" name="Text 39"/>
+          <p:cNvPr id="41" name="Text 37"/>
           <p:cNvSpPr txBox="1"/>
           <p:nvPr/>
         </p:nvSpPr>
@@ -18466,7 +18256,7 @@
       </p:sp>
       <p:sp>
         <p:nvSpPr>
-          <p:cNvPr id="43" name="Shape 40"/>
+          <p:cNvPr id="42" name="Shape 38"/>
           <p:cNvSpPr/>
           <p:nvPr/>
         </p:nvSpPr>
@@ -18491,7 +18281,7 @@
       </p:sp>
       <p:sp>
         <p:nvSpPr>
-          <p:cNvPr id="44" name="Text 41"/>
+          <p:cNvPr id="43" name="Text 39"/>
           <p:cNvSpPr txBox="1"/>
           <p:nvPr/>
         </p:nvSpPr>
@@ -18533,7 +18323,7 @@
       </p:sp>
       <p:sp>
         <p:nvSpPr>
-          <p:cNvPr id="45" name="Shape 42"/>
+          <p:cNvPr id="44" name="Shape 40"/>
           <p:cNvSpPr/>
           <p:nvPr/>
         </p:nvSpPr>
@@ -18558,7 +18348,7 @@
       </p:sp>
       <p:sp>
         <p:nvSpPr>
-          <p:cNvPr id="46" name="Text 43"/>
+          <p:cNvPr id="45" name="Text 41"/>
           <p:cNvSpPr txBox="1"/>
           <p:nvPr/>
         </p:nvSpPr>
@@ -18600,7 +18390,7 @@
       </p:sp>
       <p:sp>
         <p:nvSpPr>
-          <p:cNvPr id="47" name="Shape 44"/>
+          <p:cNvPr id="46" name="Shape 42"/>
           <p:cNvSpPr/>
           <p:nvPr/>
         </p:nvSpPr>
@@ -18625,7 +18415,7 @@
       </p:sp>
       <p:sp>
         <p:nvSpPr>
-          <p:cNvPr id="48" name="Text 45"/>
+          <p:cNvPr id="47" name="Text 43"/>
           <p:cNvSpPr txBox="1"/>
           <p:nvPr/>
         </p:nvSpPr>
@@ -18667,7 +18457,7 @@
       </p:sp>
       <p:sp>
         <p:nvSpPr>
-          <p:cNvPr id="49" name="Shape 46"/>
+          <p:cNvPr id="48" name="Shape 44"/>
           <p:cNvSpPr/>
           <p:nvPr/>
         </p:nvSpPr>
@@ -18692,7 +18482,7 @@
       </p:sp>
       <p:sp>
         <p:nvSpPr>
-          <p:cNvPr id="50" name="Shape 47"/>
+          <p:cNvPr id="49" name="Shape 45"/>
           <p:cNvSpPr/>
           <p:nvPr/>
         </p:nvSpPr>
@@ -18717,7 +18507,7 @@
       </p:sp>
       <p:sp>
         <p:nvSpPr>
-          <p:cNvPr id="51" name="Text 48"/>
+          <p:cNvPr id="50" name="Text 46"/>
           <p:cNvSpPr txBox="1"/>
           <p:nvPr/>
         </p:nvSpPr>
@@ -18759,7 +18549,7 @@
       </p:sp>
       <p:sp>
         <p:nvSpPr>
-          <p:cNvPr id="52" name="Shape 49"/>
+          <p:cNvPr id="51" name="Shape 47"/>
           <p:cNvSpPr/>
           <p:nvPr/>
         </p:nvSpPr>
@@ -18784,7 +18574,7 @@
       </p:sp>
       <p:sp>
         <p:nvSpPr>
-          <p:cNvPr id="53" name="Text 50"/>
+          <p:cNvPr id="52" name="Text 48"/>
           <p:cNvSpPr txBox="1"/>
           <p:nvPr/>
         </p:nvSpPr>
@@ -18826,7 +18616,7 @@
       </p:sp>
       <p:sp>
         <p:nvSpPr>
-          <p:cNvPr id="54" name="Shape 51"/>
+          <p:cNvPr id="53" name="Shape 49"/>
           <p:cNvSpPr/>
           <p:nvPr/>
         </p:nvSpPr>
@@ -18851,7 +18641,7 @@
       </p:sp>
       <p:sp>
         <p:nvSpPr>
-          <p:cNvPr id="55" name="Text 52"/>
+          <p:cNvPr id="54" name="Text 50"/>
           <p:cNvSpPr txBox="1"/>
           <p:nvPr/>
         </p:nvSpPr>
@@ -18893,7 +18683,7 @@
       </p:sp>
       <p:sp>
         <p:nvSpPr>
-          <p:cNvPr id="56" name="Shape 53"/>
+          <p:cNvPr id="55" name="Shape 51"/>
           <p:cNvSpPr/>
           <p:nvPr/>
         </p:nvSpPr>
@@ -18918,7 +18708,7 @@
       </p:sp>
       <p:sp>
         <p:nvSpPr>
-          <p:cNvPr id="57" name="Text 54"/>
+          <p:cNvPr id="56" name="Text 52"/>
           <p:cNvSpPr txBox="1"/>
           <p:nvPr/>
         </p:nvSpPr>
@@ -18960,7 +18750,7 @@
       </p:sp>
       <p:sp>
         <p:nvSpPr>
-          <p:cNvPr id="58" name="Shape 55"/>
+          <p:cNvPr id="57" name="Shape 53"/>
           <p:cNvSpPr/>
           <p:nvPr/>
         </p:nvSpPr>
@@ -18985,7 +18775,7 @@
       </p:sp>
       <p:sp>
         <p:nvSpPr>
-          <p:cNvPr id="59" name="Text 56"/>
+          <p:cNvPr id="58" name="Text 54"/>
           <p:cNvSpPr txBox="1"/>
           <p:nvPr/>
         </p:nvSpPr>
@@ -19027,7 +18817,7 @@
       </p:sp>
       <p:sp>
         <p:nvSpPr>
-          <p:cNvPr id="60" name="Shape 57"/>
+          <p:cNvPr id="59" name="Shape 55"/>
           <p:cNvSpPr/>
           <p:nvPr/>
         </p:nvSpPr>
@@ -19050,7 +18840,7 @@
       </p:sp>
       <p:sp>
         <p:nvSpPr>
-          <p:cNvPr id="61" name="Text 58"/>
+          <p:cNvPr id="60" name="Text 56"/>
           <p:cNvSpPr txBox="1"/>
           <p:nvPr/>
         </p:nvSpPr>
@@ -19092,7 +18882,7 @@
       </p:sp>
       <p:sp>
         <p:nvSpPr>
-          <p:cNvPr id="62" name="Shape 59"/>
+          <p:cNvPr id="61" name="Shape 57"/>
           <p:cNvSpPr/>
           <p:nvPr/>
         </p:nvSpPr>
@@ -19117,7 +18907,7 @@
       </p:sp>
       <p:sp>
         <p:nvSpPr>
-          <p:cNvPr id="63" name="Text 60"/>
+          <p:cNvPr id="62" name="Text 58"/>
           <p:cNvSpPr txBox="1"/>
           <p:nvPr/>
         </p:nvSpPr>
@@ -19159,7 +18949,7 @@
       </p:sp>
       <p:sp>
         <p:nvSpPr>
-          <p:cNvPr id="64" name="Text 61"/>
+          <p:cNvPr id="63" name="Text 59"/>
           <p:cNvSpPr txBox="1"/>
           <p:nvPr/>
         </p:nvSpPr>
@@ -19201,7 +18991,7 @@
       </p:sp>
       <p:sp>
         <p:nvSpPr>
-          <p:cNvPr id="65" name="Text 62"/>
+          <p:cNvPr id="64" name="Text 60"/>
           <p:cNvSpPr txBox="1"/>
           <p:nvPr/>
         </p:nvSpPr>
@@ -19260,7 +19050,7 @@
       </p:sp>
       <p:sp>
         <p:nvSpPr>
-          <p:cNvPr id="66" name="Text 63"/>
+          <p:cNvPr id="65" name="Text 61"/>
           <p:cNvSpPr txBox="1"/>
           <p:nvPr/>
         </p:nvSpPr>
@@ -19319,7 +19109,7 @@
       </p:sp>
       <p:sp>
         <p:nvSpPr>
-          <p:cNvPr id="67" name="Text 64"/>
+          <p:cNvPr id="66" name="Text 62"/>
           <p:cNvSpPr txBox="1"/>
           <p:nvPr/>
         </p:nvSpPr>
@@ -19378,7 +19168,7 @@
       </p:sp>
       <p:sp>
         <p:nvSpPr>
-          <p:cNvPr id="68" name="Text 65"/>
+          <p:cNvPr id="67" name="Text 63"/>
           <p:cNvSpPr txBox="1"/>
           <p:nvPr/>
         </p:nvSpPr>
@@ -19437,7 +19227,7 @@
       </p:sp>
       <p:sp>
         <p:nvSpPr>
-          <p:cNvPr id="69" name="Shape 66"/>
+          <p:cNvPr id="68" name="Shape 64"/>
           <p:cNvSpPr/>
           <p:nvPr/>
         </p:nvSpPr>
@@ -19460,7 +19250,7 @@
       </p:sp>
       <p:sp>
         <p:nvSpPr>
-          <p:cNvPr id="70" name="Text 67"/>
+          <p:cNvPr id="69" name="Text 65"/>
           <p:cNvSpPr txBox="1"/>
           <p:nvPr/>
         </p:nvSpPr>
@@ -19502,7 +19292,7 @@
       </p:sp>
       <p:sp>
         <p:nvSpPr>
-          <p:cNvPr id="71" name="Shape 68"/>
+          <p:cNvPr id="70" name="Shape 66"/>
           <p:cNvSpPr/>
           <p:nvPr/>
         </p:nvSpPr>
@@ -19527,7 +19317,7 @@
       </p:sp>
       <p:sp>
         <p:nvSpPr>
-          <p:cNvPr id="72" name="Text 69"/>
+          <p:cNvPr id="71" name="Text 67"/>
           <p:cNvSpPr txBox="1"/>
           <p:nvPr/>
         </p:nvSpPr>
@@ -20727,7 +20517,7 @@
       </p:graphicFrame>
       <p:sp>
         <p:nvSpPr>
-          <p:cNvPr id="74" name="Shape 70"/>
+          <p:cNvPr id="73" name="Shape 68"/>
           <p:cNvSpPr/>
           <p:nvPr/>
         </p:nvSpPr>
@@ -20750,7 +20540,7 @@
       </p:sp>
       <p:sp>
         <p:nvSpPr>
-          <p:cNvPr id="75" name="Text 71"/>
+          <p:cNvPr id="74" name="Text 69"/>
           <p:cNvSpPr txBox="1"/>
           <p:nvPr/>
         </p:nvSpPr>
@@ -20792,7 +20582,7 @@
       </p:sp>
       <p:sp>
         <p:nvSpPr>
-          <p:cNvPr id="76" name="Shape 72"/>
+          <p:cNvPr id="75" name="Shape 70"/>
           <p:cNvSpPr/>
           <p:nvPr/>
         </p:nvSpPr>
@@ -20817,7 +20607,7 @@
       </p:sp>
       <p:sp>
         <p:nvSpPr>
-          <p:cNvPr id="77" name="Text 73"/>
+          <p:cNvPr id="76" name="Text 71"/>
           <p:cNvSpPr txBox="1"/>
           <p:nvPr/>
         </p:nvSpPr>
@@ -20859,7 +20649,7 @@
       </p:sp>
       <p:sp>
         <p:nvSpPr>
-          <p:cNvPr id="78" name="Text 74"/>
+          <p:cNvPr id="77" name="Text 72"/>
           <p:cNvSpPr txBox="1"/>
           <p:nvPr/>
         </p:nvSpPr>
@@ -20901,7 +20691,7 @@
       </p:sp>
       <p:sp>
         <p:nvSpPr>
-          <p:cNvPr id="79" name="Text 75"/>
+          <p:cNvPr id="78" name="Text 73"/>
           <p:cNvSpPr txBox="1"/>
           <p:nvPr/>
         </p:nvSpPr>
@@ -20960,7 +20750,7 @@
       </p:sp>
       <p:sp>
         <p:nvSpPr>
-          <p:cNvPr id="80" name="Text 76"/>
+          <p:cNvPr id="79" name="Text 74"/>
           <p:cNvSpPr txBox="1"/>
           <p:nvPr/>
         </p:nvSpPr>
@@ -21019,7 +20809,7 @@
       </p:sp>
       <p:sp>
         <p:nvSpPr>
-          <p:cNvPr id="81" name="Shape 77"/>
+          <p:cNvPr id="80" name="Shape 75"/>
           <p:cNvSpPr/>
           <p:nvPr/>
         </p:nvSpPr>
@@ -21042,7 +20832,7 @@
       </p:sp>
       <p:sp>
         <p:nvSpPr>
-          <p:cNvPr id="82" name="Text 78"/>
+          <p:cNvPr id="81" name="Text 76"/>
           <p:cNvSpPr txBox="1"/>
           <p:nvPr/>
         </p:nvSpPr>
@@ -21084,7 +20874,7 @@
       </p:sp>
       <p:sp>
         <p:nvSpPr>
-          <p:cNvPr id="83" name="Shape 79"/>
+          <p:cNvPr id="82" name="Shape 77"/>
           <p:cNvSpPr/>
           <p:nvPr/>
         </p:nvSpPr>
@@ -21109,7 +20899,7 @@
       </p:sp>
       <p:sp>
         <p:nvSpPr>
-          <p:cNvPr id="84" name="Text 80"/>
+          <p:cNvPr id="83" name="Text 78"/>
           <p:cNvSpPr txBox="1"/>
           <p:nvPr/>
         </p:nvSpPr>
@@ -24187,7 +23977,7 @@
       </p:graphicFrame>
       <p:sp>
         <p:nvSpPr>
-          <p:cNvPr id="86" name="Shape 81"/>
+          <p:cNvPr id="85" name="Shape 79"/>
           <p:cNvSpPr/>
           <p:nvPr/>
         </p:nvSpPr>
@@ -24210,7 +24000,7 @@
       </p:sp>
       <p:sp>
         <p:nvSpPr>
-          <p:cNvPr id="87" name="Text 82"/>
+          <p:cNvPr id="86" name="Text 80"/>
           <p:cNvSpPr txBox="1"/>
           <p:nvPr/>
         </p:nvSpPr>
@@ -24252,7 +24042,7 @@
       </p:sp>
       <p:sp>
         <p:nvSpPr>
-          <p:cNvPr id="88" name="Shape 83"/>
+          <p:cNvPr id="87" name="Shape 81"/>
           <p:cNvSpPr/>
           <p:nvPr/>
         </p:nvSpPr>
@@ -24277,7 +24067,7 @@
       </p:sp>
       <p:sp>
         <p:nvSpPr>
-          <p:cNvPr id="89" name="Text 84"/>
+          <p:cNvPr id="88" name="Text 82"/>
           <p:cNvSpPr txBox="1"/>
           <p:nvPr/>
         </p:nvSpPr>
@@ -24319,7 +24109,7 @@
       </p:sp>
       <p:sp>
         <p:nvSpPr>
-          <p:cNvPr id="90" name="Shape 85"/>
+          <p:cNvPr id="89" name="Shape 83"/>
           <p:cNvSpPr/>
           <p:nvPr/>
         </p:nvSpPr>
@@ -24344,7 +24134,7 @@
       </p:sp>
       <p:sp>
         <p:nvSpPr>
-          <p:cNvPr id="91" name="Text 86"/>
+          <p:cNvPr id="90" name="Text 84"/>
           <p:cNvSpPr txBox="1"/>
           <p:nvPr/>
         </p:nvSpPr>
@@ -24403,7 +24193,7 @@
       </p:sp>
       <p:sp>
         <p:nvSpPr>
-          <p:cNvPr id="92" name="Shape 87"/>
+          <p:cNvPr id="91" name="Shape 85"/>
           <p:cNvSpPr/>
           <p:nvPr/>
         </p:nvSpPr>
@@ -24428,7 +24218,7 @@
       </p:sp>
       <p:sp>
         <p:nvSpPr>
-          <p:cNvPr id="93" name="Text 88"/>
+          <p:cNvPr id="92" name="Text 86"/>
           <p:cNvSpPr txBox="1"/>
           <p:nvPr/>
         </p:nvSpPr>
@@ -24487,7 +24277,7 @@
       </p:sp>
       <p:sp>
         <p:nvSpPr>
-          <p:cNvPr id="94" name="Shape 89"/>
+          <p:cNvPr id="93" name="Shape 87"/>
           <p:cNvSpPr/>
           <p:nvPr/>
         </p:nvSpPr>
@@ -24512,7 +24302,7 @@
       </p:sp>
       <p:sp>
         <p:nvSpPr>
-          <p:cNvPr id="95" name="Text 90"/>
+          <p:cNvPr id="94" name="Text 88"/>
           <p:cNvSpPr txBox="1"/>
           <p:nvPr/>
         </p:nvSpPr>
@@ -24571,7 +24361,7 @@
       </p:sp>
       <p:sp>
         <p:nvSpPr>
-          <p:cNvPr id="96" name="Shape 91"/>
+          <p:cNvPr id="95" name="Shape 89"/>
           <p:cNvSpPr/>
           <p:nvPr/>
         </p:nvSpPr>
@@ -24596,7 +24386,7 @@
       </p:sp>
       <p:sp>
         <p:nvSpPr>
-          <p:cNvPr id="97" name="Text 92"/>
+          <p:cNvPr id="96" name="Text 90"/>
           <p:cNvSpPr txBox="1"/>
           <p:nvPr/>
         </p:nvSpPr>
@@ -24655,7 +24445,7 @@
       </p:sp>
       <p:sp>
         <p:nvSpPr>
-          <p:cNvPr id="98" name="Shape 93"/>
+          <p:cNvPr id="97" name="Shape 91"/>
           <p:cNvSpPr/>
           <p:nvPr/>
         </p:nvSpPr>
@@ -24680,7 +24470,7 @@
       </p:sp>
       <p:sp>
         <p:nvSpPr>
-          <p:cNvPr id="99" name="Text 94"/>
+          <p:cNvPr id="98" name="Text 92"/>
           <p:cNvSpPr txBox="1"/>
           <p:nvPr/>
         </p:nvSpPr>
@@ -24739,7 +24529,7 @@
       </p:sp>
       <p:sp>
         <p:nvSpPr>
-          <p:cNvPr id="100" name="Shape 95"/>
+          <p:cNvPr id="99" name="Shape 93"/>
           <p:cNvSpPr/>
           <p:nvPr/>
         </p:nvSpPr>
@@ -24762,7 +24552,7 @@
       </p:sp>
       <p:sp>
         <p:nvSpPr>
-          <p:cNvPr id="101" name="Text 96"/>
+          <p:cNvPr id="100" name="Text 94"/>
           <p:cNvSpPr txBox="1"/>
           <p:nvPr/>
         </p:nvSpPr>

</xml_diff>